<commit_message>
Discovery Task / Update Stats Service
The Discovery Task is simply an "evolution" of the aimless wandering task which is now unused.
The Discovery samples 8 random points and evaluates which one would be best depending on:
1. distance
2. current direction alignment
The priority of distance vs direction alignment is determined by a variable.
-------------------------------------
Implemented an Update Stats Service which always runs on the Selector. It simply updates the health and stamina which will be used in the future.
</commit_message>
<xml_diff>
--- a/GPP_ZombieAI_AdamovDaniel_2DAE10.pptx
+++ b/GPP_ZombieAI_AdamovDaniel_2DAE10.pptx
@@ -405,7 +405,7 @@
           <a:p>
             <a:fld id="{82085877-2B37-48E7-8B6D-4D4ED486130A}" type="datetimeFigureOut">
               <a:rPr lang="en-BE" smtClean="0"/>
-              <a:t>11/28/2023</a:t>
+              <a:t>05/31/2026</a:t>
             </a:fld>
             <a:endParaRPr lang="en-BE"/>
           </a:p>
@@ -605,7 +605,7 @@
           <a:p>
             <a:fld id="{82085877-2B37-48E7-8B6D-4D4ED486130A}" type="datetimeFigureOut">
               <a:rPr lang="en-BE" smtClean="0"/>
-              <a:t>11/28/2023</a:t>
+              <a:t>05/31/2026</a:t>
             </a:fld>
             <a:endParaRPr lang="en-BE"/>
           </a:p>
@@ -815,7 +815,7 @@
           <a:p>
             <a:fld id="{82085877-2B37-48E7-8B6D-4D4ED486130A}" type="datetimeFigureOut">
               <a:rPr lang="en-BE" smtClean="0"/>
-              <a:t>11/28/2023</a:t>
+              <a:t>05/31/2026</a:t>
             </a:fld>
             <a:endParaRPr lang="en-BE"/>
           </a:p>
@@ -1015,7 +1015,7 @@
           <a:p>
             <a:fld id="{82085877-2B37-48E7-8B6D-4D4ED486130A}" type="datetimeFigureOut">
               <a:rPr lang="en-BE" smtClean="0"/>
-              <a:t>11/28/2023</a:t>
+              <a:t>05/31/2026</a:t>
             </a:fld>
             <a:endParaRPr lang="en-BE"/>
           </a:p>
@@ -1291,7 +1291,7 @@
           <a:p>
             <a:fld id="{82085877-2B37-48E7-8B6D-4D4ED486130A}" type="datetimeFigureOut">
               <a:rPr lang="en-BE" smtClean="0"/>
-              <a:t>11/28/2023</a:t>
+              <a:t>05/31/2026</a:t>
             </a:fld>
             <a:endParaRPr lang="en-BE"/>
           </a:p>
@@ -1559,7 +1559,7 @@
           <a:p>
             <a:fld id="{82085877-2B37-48E7-8B6D-4D4ED486130A}" type="datetimeFigureOut">
               <a:rPr lang="en-BE" smtClean="0"/>
-              <a:t>11/28/2023</a:t>
+              <a:t>05/31/2026</a:t>
             </a:fld>
             <a:endParaRPr lang="en-BE"/>
           </a:p>
@@ -1974,7 +1974,7 @@
           <a:p>
             <a:fld id="{82085877-2B37-48E7-8B6D-4D4ED486130A}" type="datetimeFigureOut">
               <a:rPr lang="en-BE" smtClean="0"/>
-              <a:t>11/28/2023</a:t>
+              <a:t>05/31/2026</a:t>
             </a:fld>
             <a:endParaRPr lang="en-BE"/>
           </a:p>
@@ -2116,7 +2116,7 @@
           <a:p>
             <a:fld id="{82085877-2B37-48E7-8B6D-4D4ED486130A}" type="datetimeFigureOut">
               <a:rPr lang="en-BE" smtClean="0"/>
-              <a:t>11/28/2023</a:t>
+              <a:t>05/31/2026</a:t>
             </a:fld>
             <a:endParaRPr lang="en-BE"/>
           </a:p>
@@ -2229,7 +2229,7 @@
           <a:p>
             <a:fld id="{82085877-2B37-48E7-8B6D-4D4ED486130A}" type="datetimeFigureOut">
               <a:rPr lang="en-BE" smtClean="0"/>
-              <a:t>11/28/2023</a:t>
+              <a:t>05/31/2026</a:t>
             </a:fld>
             <a:endParaRPr lang="en-BE"/>
           </a:p>
@@ -2542,7 +2542,7 @@
           <a:p>
             <a:fld id="{82085877-2B37-48E7-8B6D-4D4ED486130A}" type="datetimeFigureOut">
               <a:rPr lang="en-BE" smtClean="0"/>
-              <a:t>11/28/2023</a:t>
+              <a:t>05/31/2026</a:t>
             </a:fld>
             <a:endParaRPr lang="en-BE"/>
           </a:p>
@@ -2831,7 +2831,7 @@
           <a:p>
             <a:fld id="{82085877-2B37-48E7-8B6D-4D4ED486130A}" type="datetimeFigureOut">
               <a:rPr lang="en-BE" smtClean="0"/>
-              <a:t>11/28/2023</a:t>
+              <a:t>05/31/2026</a:t>
             </a:fld>
             <a:endParaRPr lang="en-BE"/>
           </a:p>
@@ -3074,7 +3074,7 @@
           <a:p>
             <a:fld id="{82085877-2B37-48E7-8B6D-4D4ED486130A}" type="datetimeFigureOut">
               <a:rPr lang="en-BE" smtClean="0"/>
-              <a:t>11/28/2023</a:t>
+              <a:t>05/31/2026</a:t>
             </a:fld>
             <a:endParaRPr lang="en-BE"/>
           </a:p>
@@ -4116,6 +4116,32 @@
             </a:r>
           </a:p>
           <a:p>
+            <a:endParaRPr lang="en-US" i="1" dirty="0">
+              <a:solidFill>
+                <a:schemeClr val="bg1">
+                  <a:lumMod val="75000"/>
+                </a:schemeClr>
+              </a:solidFill>
+            </a:endParaRPr>
+          </a:p>
+          <a:p>
+            <a:pPr marL="0" indent="0">
+              <a:buNone/>
+            </a:pPr>
+            <a:r>
+              <a:rPr lang="en-US" sz="1600" b="1" dirty="0"/>
+              <a:t>I decided to first name the least-urgent task Exploration. After thinking deeper, I thought that Discover would be a better name since the survivor starts with 0 memory – it knows of 0 houses. </a:t>
+            </a:r>
+            <a:r>
+              <a:rPr lang="en-US" sz="1600" b="1"/>
+              <a:t>So, </a:t>
+            </a:r>
+            <a:r>
+              <a:rPr lang="en-US" sz="1600" b="1" dirty="0"/>
+              <a:t>it starts trying to DISCOVER houses which they can then explore.</a:t>
+            </a:r>
+          </a:p>
+          <a:p>
             <a:pPr marL="0" indent="0">
               <a:buNone/>
             </a:pPr>
@@ -4535,12 +4561,18 @@
 </file>
 
 <file path=customXml/item1.xml><?xml version="1.0" encoding="utf-8"?>
-<?mso-contentType ?>
-<FormTemplates xmlns="http://schemas.microsoft.com/sharepoint/v3/contenttype/forms">
-  <Display>DocumentLibraryForm</Display>
-  <Edit>DocumentLibraryForm</Edit>
-  <New>DocumentLibraryForm</New>
-</FormTemplates>
+<p:properties xmlns:p="http://schemas.microsoft.com/office/2006/metadata/properties" xmlns:xsi="http://www.w3.org/2001/XMLSchema-instance" xmlns:pc="http://schemas.microsoft.com/office/infopath/2007/PartnerControls">
+  <documentManagement>
+    <IconOverlay xmlns="http://schemas.microsoft.com/sharepoint/v4" xsi:nil="true"/>
+    <TaxCatchAll xmlns="128482ec-0431-40d5-ab26-89ea2a4f3ccd" xsi:nil="true"/>
+    <m99485b88215436a82099f8287cba0b0 xmlns="128482ec-0431-40d5-ab26-89ea2a4f3ccd">
+      <Terms xmlns="http://schemas.microsoft.com/office/infopath/2007/PartnerControls"/>
+    </m99485b88215436a82099f8287cba0b0>
+    <lcf76f155ced4ddcb4097134ff3c332f xmlns="60eb0cf4-ae2a-4762-800a-cb593b869ecb">
+      <Terms xmlns="http://schemas.microsoft.com/office/infopath/2007/PartnerControls"/>
+    </lcf76f155ced4ddcb4097134ff3c332f>
+  </documentManagement>
+</p:properties>
 </file>
 
 <file path=customXml/item2.xml><?xml version="1.0" encoding="utf-8"?>
@@ -4817,24 +4849,22 @@
 </file>
 
 <file path=customXml/item3.xml><?xml version="1.0" encoding="utf-8"?>
-<p:properties xmlns:p="http://schemas.microsoft.com/office/2006/metadata/properties" xmlns:xsi="http://www.w3.org/2001/XMLSchema-instance" xmlns:pc="http://schemas.microsoft.com/office/infopath/2007/PartnerControls">
-  <documentManagement>
-    <IconOverlay xmlns="http://schemas.microsoft.com/sharepoint/v4" xsi:nil="true"/>
-    <TaxCatchAll xmlns="128482ec-0431-40d5-ab26-89ea2a4f3ccd" xsi:nil="true"/>
-    <m99485b88215436a82099f8287cba0b0 xmlns="128482ec-0431-40d5-ab26-89ea2a4f3ccd">
-      <Terms xmlns="http://schemas.microsoft.com/office/infopath/2007/PartnerControls"/>
-    </m99485b88215436a82099f8287cba0b0>
-    <lcf76f155ced4ddcb4097134ff3c332f xmlns="60eb0cf4-ae2a-4762-800a-cb593b869ecb">
-      <Terms xmlns="http://schemas.microsoft.com/office/infopath/2007/PartnerControls"/>
-    </lcf76f155ced4ddcb4097134ff3c332f>
-  </documentManagement>
-</p:properties>
+<?mso-contentType ?>
+<FormTemplates xmlns="http://schemas.microsoft.com/sharepoint/v3/contenttype/forms">
+  <Display>DocumentLibraryForm</Display>
+  <Edit>DocumentLibraryForm</Edit>
+  <New>DocumentLibraryForm</New>
+</FormTemplates>
 </file>
 
 <file path=customXml/itemProps1.xml><?xml version="1.0" encoding="utf-8"?>
-<ds:datastoreItem xmlns:ds="http://schemas.openxmlformats.org/officeDocument/2006/customXml" ds:itemID="{AF8EC6D1-CB19-4400-AD0A-0C75CD884AEA}">
+<ds:datastoreItem xmlns:ds="http://schemas.openxmlformats.org/officeDocument/2006/customXml" ds:itemID="{B743389A-7EE0-4951-8919-E91DD69E3687}">
   <ds:schemaRefs>
-    <ds:schemaRef ds:uri="http://schemas.microsoft.com/sharepoint/v3/contenttype/forms"/>
+    <ds:schemaRef ds:uri="128482ec-0431-40d5-ab26-89ea2a4f3ccd"/>
+    <ds:schemaRef ds:uri="http://schemas.microsoft.com/office/2006/metadata/properties"/>
+    <ds:schemaRef ds:uri="http://schemas.microsoft.com/office/infopath/2007/PartnerControls"/>
+    <ds:schemaRef ds:uri="http://schemas.microsoft.com/sharepoint/v4"/>
+    <ds:schemaRef ds:uri="60eb0cf4-ae2a-4762-800a-cb593b869ecb"/>
   </ds:schemaRefs>
 </ds:datastoreItem>
 </file>
@@ -4861,13 +4891,9 @@
 </file>
 
 <file path=customXml/itemProps3.xml><?xml version="1.0" encoding="utf-8"?>
-<ds:datastoreItem xmlns:ds="http://schemas.openxmlformats.org/officeDocument/2006/customXml" ds:itemID="{B743389A-7EE0-4951-8919-E91DD69E3687}">
+<ds:datastoreItem xmlns:ds="http://schemas.openxmlformats.org/officeDocument/2006/customXml" ds:itemID="{AF8EC6D1-CB19-4400-AD0A-0C75CD884AEA}">
   <ds:schemaRefs>
-    <ds:schemaRef ds:uri="128482ec-0431-40d5-ab26-89ea2a4f3ccd"/>
-    <ds:schemaRef ds:uri="http://schemas.microsoft.com/office/2006/metadata/properties"/>
-    <ds:schemaRef ds:uri="http://schemas.microsoft.com/office/infopath/2007/PartnerControls"/>
-    <ds:schemaRef ds:uri="http://schemas.microsoft.com/sharepoint/v4"/>
-    <ds:schemaRef ds:uri="60eb0cf4-ae2a-4762-800a-cb593b869ecb"/>
+    <ds:schemaRef ds:uri="http://schemas.microsoft.com/sharepoint/v3/contenttype/forms"/>
   </ds:schemaRefs>
 </ds:datastoreItem>
 </file>
</xml_diff>

<commit_message>
Perception of Zombie, Item, House
Started implementation of the "memorization" of already seen actors or actors that have damages the survivor.
The OnPerceptionUpdated method checks the AISense type and calls HandleDamage or HandleSight depending on which type it is.
-------------------------------------
Created 3 structs with the base being PerceptedActor and the other being specific for an Item and House. These structs hold the memorizeable information for each type.
-------------------------------------
Handle Sight checks if the current actor is already in one of the TArrays for Zombies, Items or Houses and updates the visible, location and time flags as well as add it to the specific TArray is it is not in it YET.
</commit_message>
<xml_diff>
--- a/GPP_ZombieAI_AdamovDaniel_2DAE10.pptx
+++ b/GPP_ZombieAI_AdamovDaniel_2DAE10.pptx
@@ -4130,15 +4130,46 @@
             </a:pPr>
             <a:r>
               <a:rPr lang="en-US" sz="1600" b="1" dirty="0"/>
-              <a:t>I decided to first name the least-urgent task Exploration. After thinking deeper, I thought that Discover would be a better name since the survivor starts with 0 memory – it knows of 0 houses. </a:t>
-            </a:r>
-            <a:r>
-              <a:rPr lang="en-US" sz="1600" b="1"/>
-              <a:t>So, </a:t>
-            </a:r>
+              <a:t>I decided to first name the least-urgent task Exploration. After thinking deeper, I thought that Discover would be a better name since the survivor starts with 0 memory – it knows of 0 houses. So, it starts trying to DISCOVER houses which they can then explore.</a:t>
+            </a:r>
+          </a:p>
+          <a:p>
+            <a:pPr marL="0" indent="0">
+              <a:buNone/>
+            </a:pPr>
+            <a:endParaRPr lang="en-US" sz="1600" b="1" dirty="0"/>
+          </a:p>
+          <a:p>
+            <a:pPr marL="0" indent="0">
+              <a:buNone/>
+            </a:pPr>
             <a:r>
               <a:rPr lang="en-US" sz="1600" b="1" dirty="0"/>
-              <a:t>it starts trying to DISCOVER houses which they can then explore.</a:t>
+              <a:t>Perception – produces knowledge/memory of surroundings. When the Survivor doesn’t look at something, some data is still kept in the BB – </a:t>
+            </a:r>
+            <a:r>
+              <a:rPr lang="en-US" sz="1600" b="1" dirty="0" err="1"/>
+              <a:t>ThreatActor</a:t>
+            </a:r>
+            <a:r>
+              <a:rPr lang="en-US" sz="1600" b="1" dirty="0"/>
+              <a:t>, </a:t>
+            </a:r>
+            <a:r>
+              <a:rPr lang="en-US" sz="1600" b="1" dirty="0" err="1"/>
+              <a:t>TargetItem</a:t>
+            </a:r>
+            <a:r>
+              <a:rPr lang="en-US" sz="1600" b="1" dirty="0"/>
+              <a:t>, </a:t>
+            </a:r>
+            <a:r>
+              <a:rPr lang="en-US" sz="1600" b="1" dirty="0" err="1"/>
+              <a:t>KnownHouseTarget</a:t>
+            </a:r>
+            <a:r>
+              <a:rPr lang="en-US" sz="1600" b="1" dirty="0"/>
+              <a:t>. The BT then decides what do with this information.</a:t>
             </a:r>
           </a:p>
           <a:p>
@@ -4561,18 +4592,12 @@
 </file>
 
 <file path=customXml/item1.xml><?xml version="1.0" encoding="utf-8"?>
-<p:properties xmlns:p="http://schemas.microsoft.com/office/2006/metadata/properties" xmlns:xsi="http://www.w3.org/2001/XMLSchema-instance" xmlns:pc="http://schemas.microsoft.com/office/infopath/2007/PartnerControls">
-  <documentManagement>
-    <IconOverlay xmlns="http://schemas.microsoft.com/sharepoint/v4" xsi:nil="true"/>
-    <TaxCatchAll xmlns="128482ec-0431-40d5-ab26-89ea2a4f3ccd" xsi:nil="true"/>
-    <m99485b88215436a82099f8287cba0b0 xmlns="128482ec-0431-40d5-ab26-89ea2a4f3ccd">
-      <Terms xmlns="http://schemas.microsoft.com/office/infopath/2007/PartnerControls"/>
-    </m99485b88215436a82099f8287cba0b0>
-    <lcf76f155ced4ddcb4097134ff3c332f xmlns="60eb0cf4-ae2a-4762-800a-cb593b869ecb">
-      <Terms xmlns="http://schemas.microsoft.com/office/infopath/2007/PartnerControls"/>
-    </lcf76f155ced4ddcb4097134ff3c332f>
-  </documentManagement>
-</p:properties>
+<?mso-contentType ?>
+<FormTemplates xmlns="http://schemas.microsoft.com/sharepoint/v3/contenttype/forms">
+  <Display>DocumentLibraryForm</Display>
+  <Edit>DocumentLibraryForm</Edit>
+  <New>DocumentLibraryForm</New>
+</FormTemplates>
 </file>
 
 <file path=customXml/item2.xml><?xml version="1.0" encoding="utf-8"?>
@@ -4849,22 +4874,24 @@
 </file>
 
 <file path=customXml/item3.xml><?xml version="1.0" encoding="utf-8"?>
-<?mso-contentType ?>
-<FormTemplates xmlns="http://schemas.microsoft.com/sharepoint/v3/contenttype/forms">
-  <Display>DocumentLibraryForm</Display>
-  <Edit>DocumentLibraryForm</Edit>
-  <New>DocumentLibraryForm</New>
-</FormTemplates>
+<p:properties xmlns:p="http://schemas.microsoft.com/office/2006/metadata/properties" xmlns:xsi="http://www.w3.org/2001/XMLSchema-instance" xmlns:pc="http://schemas.microsoft.com/office/infopath/2007/PartnerControls">
+  <documentManagement>
+    <IconOverlay xmlns="http://schemas.microsoft.com/sharepoint/v4" xsi:nil="true"/>
+    <TaxCatchAll xmlns="128482ec-0431-40d5-ab26-89ea2a4f3ccd" xsi:nil="true"/>
+    <m99485b88215436a82099f8287cba0b0 xmlns="128482ec-0431-40d5-ab26-89ea2a4f3ccd">
+      <Terms xmlns="http://schemas.microsoft.com/office/infopath/2007/PartnerControls"/>
+    </m99485b88215436a82099f8287cba0b0>
+    <lcf76f155ced4ddcb4097134ff3c332f xmlns="60eb0cf4-ae2a-4762-800a-cb593b869ecb">
+      <Terms xmlns="http://schemas.microsoft.com/office/infopath/2007/PartnerControls"/>
+    </lcf76f155ced4ddcb4097134ff3c332f>
+  </documentManagement>
+</p:properties>
 </file>
 
 <file path=customXml/itemProps1.xml><?xml version="1.0" encoding="utf-8"?>
-<ds:datastoreItem xmlns:ds="http://schemas.openxmlformats.org/officeDocument/2006/customXml" ds:itemID="{B743389A-7EE0-4951-8919-E91DD69E3687}">
+<ds:datastoreItem xmlns:ds="http://schemas.openxmlformats.org/officeDocument/2006/customXml" ds:itemID="{AF8EC6D1-CB19-4400-AD0A-0C75CD884AEA}">
   <ds:schemaRefs>
-    <ds:schemaRef ds:uri="128482ec-0431-40d5-ab26-89ea2a4f3ccd"/>
-    <ds:schemaRef ds:uri="http://schemas.microsoft.com/office/2006/metadata/properties"/>
-    <ds:schemaRef ds:uri="http://schemas.microsoft.com/office/infopath/2007/PartnerControls"/>
-    <ds:schemaRef ds:uri="http://schemas.microsoft.com/sharepoint/v4"/>
-    <ds:schemaRef ds:uri="60eb0cf4-ae2a-4762-800a-cb593b869ecb"/>
+    <ds:schemaRef ds:uri="http://schemas.microsoft.com/sharepoint/v3/contenttype/forms"/>
   </ds:schemaRefs>
 </ds:datastoreItem>
 </file>
@@ -4891,9 +4918,13 @@
 </file>
 
 <file path=customXml/itemProps3.xml><?xml version="1.0" encoding="utf-8"?>
-<ds:datastoreItem xmlns:ds="http://schemas.openxmlformats.org/officeDocument/2006/customXml" ds:itemID="{AF8EC6D1-CB19-4400-AD0A-0C75CD884AEA}">
+<ds:datastoreItem xmlns:ds="http://schemas.openxmlformats.org/officeDocument/2006/customXml" ds:itemID="{B743389A-7EE0-4951-8919-E91DD69E3687}">
   <ds:schemaRefs>
-    <ds:schemaRef ds:uri="http://schemas.microsoft.com/sharepoint/v3/contenttype/forms"/>
+    <ds:schemaRef ds:uri="128482ec-0431-40d5-ab26-89ea2a4f3ccd"/>
+    <ds:schemaRef ds:uri="http://schemas.microsoft.com/office/2006/metadata/properties"/>
+    <ds:schemaRef ds:uri="http://schemas.microsoft.com/office/infopath/2007/PartnerControls"/>
+    <ds:schemaRef ds:uri="http://schemas.microsoft.com/sharepoint/v4"/>
+    <ds:schemaRef ds:uri="60eb0cf4-ae2a-4762-800a-cb593b869ecb"/>
   </ds:schemaRefs>
 </ds:datastoreItem>
 </file>
</xml_diff>

<commit_message>
Select Threat / Item / House Logic - Most interesting part
Write Blackboard, which is called every Update and every time World Memory is Refreshed, sets Values to three keys - Threat Actor, Target Item and Target House.
-------------------------------------
These keys are calculated by specific logic for most - distance for house and threat/zombie.
Item is more interesting - it has specific information about priority score and distance as secondary.
</commit_message>
<xml_diff>
--- a/GPP_ZombieAI_AdamovDaniel_2DAE10.pptx
+++ b/GPP_ZombieAI_AdamovDaniel_2DAE10.pptx
@@ -3851,10 +3851,10 @@
           <a:lstStyle/>
           <a:p>
             <a:r>
-              <a:rPr lang="en-US"/>
+              <a:rPr lang="en-US" dirty="0"/>
               <a:t>Inventory</a:t>
             </a:r>
-            <a:endParaRPr lang="en-BE"/>
+            <a:endParaRPr lang="en-BE" dirty="0"/>
           </a:p>
         </p:txBody>
       </p:sp>
@@ -3899,6 +3899,458 @@
           </a:p>
           <a:p>
             <a:endParaRPr lang="en-BE" dirty="0"/>
+          </a:p>
+        </p:txBody>
+      </p:sp>
+      <p:sp>
+        <p:nvSpPr>
+          <p:cNvPr id="5" name="TextBox 4">
+            <a:extLst>
+              <a:ext uri="{FF2B5EF4-FFF2-40B4-BE49-F238E27FC236}">
+                <a16:creationId xmlns:a16="http://schemas.microsoft.com/office/drawing/2014/main" id="{1663805A-2830-C83A-A80B-D09BE1850F09}"/>
+              </a:ext>
+            </a:extLst>
+          </p:cNvPr>
+          <p:cNvSpPr txBox="1"/>
+          <p:nvPr/>
+        </p:nvSpPr>
+        <p:spPr>
+          <a:xfrm>
+            <a:off x="102794" y="2664673"/>
+            <a:ext cx="6097022" cy="1200329"/>
+          </a:xfrm>
+          <a:prstGeom prst="rect">
+            <a:avLst/>
+          </a:prstGeom>
+          <a:noFill/>
+        </p:spPr>
+        <p:txBody>
+          <a:bodyPr wrap="square">
+            <a:spAutoFit/>
+          </a:bodyPr>
+          <a:lstStyle/>
+          <a:p>
+            <a:r>
+              <a:rPr lang="en-GB" sz="1800" dirty="0" err="1"/>
+              <a:t>AActor</a:t>
+            </a:r>
+            <a:r>
+              <a:rPr lang="en-GB" sz="1800" dirty="0"/>
+              <a:t>* </a:t>
+            </a:r>
+            <a:r>
+              <a:rPr lang="en-GB" sz="1800" dirty="0" err="1"/>
+              <a:t>SelectTargetItem</a:t>
+            </a:r>
+            <a:r>
+              <a:rPr lang="en-GB" sz="1800" dirty="0"/>
+              <a:t>() </a:t>
+            </a:r>
+            <a:r>
+              <a:rPr lang="en-GB" sz="1800" dirty="0" err="1"/>
+              <a:t>const</a:t>
+            </a:r>
+            <a:r>
+              <a:rPr lang="en-GB" sz="1800" dirty="0"/>
+              <a:t>;</a:t>
+            </a:r>
+          </a:p>
+          <a:p>
+            <a:r>
+              <a:rPr lang="en-GB" sz="1800" dirty="0"/>
+              <a:t>int32 </a:t>
+            </a:r>
+            <a:r>
+              <a:rPr lang="en-GB" sz="1800" dirty="0" err="1"/>
+              <a:t>GetItemPriority</a:t>
+            </a:r>
+            <a:r>
+              <a:rPr lang="en-GB" sz="1800" dirty="0"/>
+              <a:t>(</a:t>
+            </a:r>
+            <a:r>
+              <a:rPr lang="en-GB" sz="1800" dirty="0" err="1"/>
+              <a:t>EItemType</a:t>
+            </a:r>
+            <a:r>
+              <a:rPr lang="en-GB" sz="1800" dirty="0"/>
+              <a:t> ItemType, int32 Value) </a:t>
+            </a:r>
+            <a:r>
+              <a:rPr lang="en-GB" sz="1800" dirty="0" err="1"/>
+              <a:t>const</a:t>
+            </a:r>
+            <a:r>
+              <a:rPr lang="en-GB" sz="1800" dirty="0"/>
+              <a:t>; </a:t>
+            </a:r>
+            <a:br>
+              <a:rPr lang="en-GB" sz="1800" i="1" dirty="0"/>
+            </a:br>
+            <a:r>
+              <a:rPr lang="en-GB" sz="1800" dirty="0"/>
+              <a:t>bool </a:t>
+            </a:r>
+            <a:r>
+              <a:rPr lang="en-GB" sz="1800" dirty="0" err="1"/>
+              <a:t>HasUsableWeapon</a:t>
+            </a:r>
+            <a:r>
+              <a:rPr lang="en-GB" sz="1800" dirty="0"/>
+              <a:t>() </a:t>
+            </a:r>
+            <a:r>
+              <a:rPr lang="en-GB" sz="1800" dirty="0" err="1"/>
+              <a:t>const</a:t>
+            </a:r>
+            <a:r>
+              <a:rPr lang="en-GB" sz="1800" dirty="0"/>
+              <a:t> </a:t>
+            </a:r>
+            <a:r>
+              <a:rPr lang="en-GB" sz="1800" dirty="0" err="1"/>
+              <a:t>noexcept</a:t>
+            </a:r>
+            <a:r>
+              <a:rPr lang="en-GB" sz="1800" dirty="0"/>
+              <a:t>;</a:t>
+            </a:r>
+            <a:br>
+              <a:rPr lang="en-GB" sz="1800" i="1" dirty="0"/>
+            </a:br>
+            <a:endParaRPr lang="LID4096" dirty="0"/>
+          </a:p>
+        </p:txBody>
+      </p:sp>
+      <p:sp>
+        <p:nvSpPr>
+          <p:cNvPr id="7" name="TextBox 6">
+            <a:extLst>
+              <a:ext uri="{FF2B5EF4-FFF2-40B4-BE49-F238E27FC236}">
+                <a16:creationId xmlns:a16="http://schemas.microsoft.com/office/drawing/2014/main" id="{79A5084E-9CF4-3942-9685-4BF7B41998B1}"/>
+              </a:ext>
+            </a:extLst>
+          </p:cNvPr>
+          <p:cNvSpPr txBox="1"/>
+          <p:nvPr/>
+        </p:nvSpPr>
+        <p:spPr>
+          <a:xfrm>
+            <a:off x="6350171" y="3209605"/>
+            <a:ext cx="6097022" cy="2862322"/>
+          </a:xfrm>
+          <a:prstGeom prst="rect">
+            <a:avLst/>
+          </a:prstGeom>
+          <a:noFill/>
+        </p:spPr>
+        <p:txBody>
+          <a:bodyPr wrap="square">
+            <a:spAutoFit/>
+          </a:bodyPr>
+          <a:lstStyle/>
+          <a:p>
+            <a:pPr>
+              <a:buNone/>
+            </a:pPr>
+            <a:r>
+              <a:rPr lang="en-GB" dirty="0">
+                <a:latin typeface="JetBrains Mono"/>
+              </a:rPr>
+              <a:t>Memory c</a:t>
+            </a:r>
+            <a:r>
+              <a:rPr lang="en-GB" sz="1800" dirty="0">
+                <a:effectLst/>
+                <a:latin typeface="JetBrains Mono"/>
+              </a:rPr>
+              <a:t>ompared to Zombies:</a:t>
+            </a:r>
+          </a:p>
+          <a:p>
+            <a:pPr>
+              <a:buNone/>
+            </a:pPr>
+            <a:r>
+              <a:rPr lang="en-GB" sz="1800" dirty="0" err="1">
+                <a:effectLst/>
+                <a:latin typeface="JetBrains Mono"/>
+              </a:rPr>
+              <a:t>Items.RemoveAll</a:t>
+            </a:r>
+            <a:r>
+              <a:rPr lang="en-GB" sz="1800" dirty="0">
+                <a:effectLst/>
+                <a:latin typeface="JetBrains Mono"/>
+              </a:rPr>
+              <a:t>( [](</a:t>
+            </a:r>
+            <a:r>
+              <a:rPr lang="en-GB" sz="1800" dirty="0" err="1">
+                <a:effectLst/>
+                <a:latin typeface="JetBrains Mono"/>
+              </a:rPr>
+              <a:t>const</a:t>
+            </a:r>
+            <a:r>
+              <a:rPr lang="en-GB" sz="1800" dirty="0">
+                <a:effectLst/>
+                <a:latin typeface="JetBrains Mono"/>
+              </a:rPr>
+              <a:t> </a:t>
+            </a:r>
+            <a:r>
+              <a:rPr lang="en-GB" sz="1800" dirty="0" err="1">
+                <a:effectLst/>
+                <a:latin typeface="JetBrains Mono"/>
+              </a:rPr>
+              <a:t>FPerceivedItem</a:t>
+            </a:r>
+            <a:r>
+              <a:rPr lang="en-GB" sz="1800" dirty="0">
+                <a:effectLst/>
+                <a:latin typeface="JetBrains Mono"/>
+              </a:rPr>
+              <a:t>&amp; R)</a:t>
+            </a:r>
+            <a:br>
+              <a:rPr lang="en-GB" sz="1800" dirty="0">
+                <a:effectLst/>
+                <a:latin typeface="JetBrains Mono"/>
+              </a:rPr>
+            </a:br>
+            <a:r>
+              <a:rPr lang="en-GB" sz="1800" dirty="0">
+                <a:effectLst/>
+                <a:latin typeface="JetBrains Mono"/>
+              </a:rPr>
+              <a:t>{</a:t>
+            </a:r>
+            <a:br>
+              <a:rPr lang="en-GB" sz="1800" dirty="0">
+                <a:effectLst/>
+                <a:latin typeface="JetBrains Mono"/>
+              </a:rPr>
+            </a:br>
+            <a:r>
+              <a:rPr lang="en-GB" sz="1800" dirty="0">
+                <a:effectLst/>
+                <a:latin typeface="JetBrains Mono"/>
+              </a:rPr>
+              <a:t>    return !</a:t>
+            </a:r>
+            <a:r>
+              <a:rPr lang="en-GB" sz="1800" dirty="0" err="1">
+                <a:effectLst/>
+                <a:latin typeface="JetBrains Mono"/>
+              </a:rPr>
+              <a:t>R.Actor.IsValid</a:t>
+            </a:r>
+            <a:r>
+              <a:rPr lang="en-GB" sz="1800" dirty="0">
+                <a:effectLst/>
+                <a:latin typeface="JetBrains Mono"/>
+              </a:rPr>
+              <a:t>() || </a:t>
+            </a:r>
+            <a:r>
+              <a:rPr lang="en-GB" sz="1800" dirty="0" err="1">
+                <a:effectLst/>
+                <a:latin typeface="JetBrains Mono"/>
+              </a:rPr>
+              <a:t>R.Actor</a:t>
+            </a:r>
+            <a:r>
+              <a:rPr lang="en-GB" sz="1800" dirty="0">
+                <a:effectLst/>
+                <a:latin typeface="JetBrains Mono"/>
+              </a:rPr>
+              <a:t>-&gt;</a:t>
+            </a:r>
+            <a:r>
+              <a:rPr lang="en-GB" sz="1800" dirty="0" err="1">
+                <a:effectLst/>
+                <a:latin typeface="JetBrains Mono"/>
+              </a:rPr>
+              <a:t>IsHidden</a:t>
+            </a:r>
+            <a:r>
+              <a:rPr lang="en-GB" sz="1800" dirty="0">
+                <a:effectLst/>
+                <a:latin typeface="JetBrains Mono"/>
+              </a:rPr>
+              <a:t>();</a:t>
+            </a:r>
+            <a:br>
+              <a:rPr lang="en-GB" sz="1800" dirty="0">
+                <a:effectLst/>
+                <a:latin typeface="JetBrains Mono"/>
+              </a:rPr>
+            </a:br>
+            <a:r>
+              <a:rPr lang="en-GB" sz="1800" dirty="0">
+                <a:effectLst/>
+                <a:latin typeface="JetBrains Mono"/>
+              </a:rPr>
+              <a:t>});</a:t>
+            </a:r>
+            <a:br>
+              <a:rPr lang="en-GB" sz="1800" dirty="0">
+                <a:effectLst/>
+                <a:latin typeface="JetBrains Mono"/>
+              </a:rPr>
+            </a:br>
+            <a:r>
+              <a:rPr lang="en-GB" sz="1800" dirty="0" err="1">
+                <a:effectLst/>
+                <a:latin typeface="JetBrains Mono"/>
+              </a:rPr>
+              <a:t>Zombies.RemoveAll</a:t>
+            </a:r>
+            <a:r>
+              <a:rPr lang="en-GB" sz="1800" dirty="0">
+                <a:effectLst/>
+                <a:latin typeface="JetBrains Mono"/>
+              </a:rPr>
+              <a:t>([&amp;](</a:t>
+            </a:r>
+            <a:r>
+              <a:rPr lang="en-GB" sz="1800" dirty="0" err="1">
+                <a:effectLst/>
+                <a:latin typeface="JetBrains Mono"/>
+              </a:rPr>
+              <a:t>const</a:t>
+            </a:r>
+            <a:r>
+              <a:rPr lang="en-GB" sz="1800" dirty="0">
+                <a:effectLst/>
+                <a:latin typeface="JetBrains Mono"/>
+              </a:rPr>
+              <a:t> </a:t>
+            </a:r>
+            <a:r>
+              <a:rPr lang="en-GB" sz="1800" dirty="0" err="1">
+                <a:effectLst/>
+                <a:latin typeface="JetBrains Mono"/>
+              </a:rPr>
+              <a:t>FPerceivedActor</a:t>
+            </a:r>
+            <a:r>
+              <a:rPr lang="en-GB" sz="1800" dirty="0">
+                <a:effectLst/>
+                <a:latin typeface="JetBrains Mono"/>
+              </a:rPr>
+              <a:t>&amp; R)</a:t>
+            </a:r>
+            <a:br>
+              <a:rPr lang="en-GB" sz="1800" dirty="0">
+                <a:effectLst/>
+                <a:latin typeface="JetBrains Mono"/>
+              </a:rPr>
+            </a:br>
+            <a:r>
+              <a:rPr lang="en-GB" sz="1800" dirty="0">
+                <a:effectLst/>
+                <a:latin typeface="JetBrains Mono"/>
+              </a:rPr>
+              <a:t>{</a:t>
+            </a:r>
+            <a:br>
+              <a:rPr lang="en-GB" sz="1800" dirty="0">
+                <a:effectLst/>
+                <a:latin typeface="JetBrains Mono"/>
+              </a:rPr>
+            </a:br>
+            <a:r>
+              <a:rPr lang="en-GB" sz="1800" dirty="0">
+                <a:effectLst/>
+                <a:latin typeface="JetBrains Mono"/>
+              </a:rPr>
+              <a:t>    return !</a:t>
+            </a:r>
+            <a:r>
+              <a:rPr lang="en-GB" sz="1800" dirty="0" err="1">
+                <a:effectLst/>
+                <a:latin typeface="JetBrains Mono"/>
+              </a:rPr>
+              <a:t>R.Actor.IsValid</a:t>
+            </a:r>
+            <a:r>
+              <a:rPr lang="en-GB" sz="1800" dirty="0">
+                <a:effectLst/>
+                <a:latin typeface="JetBrains Mono"/>
+              </a:rPr>
+              <a:t>() || (!</a:t>
+            </a:r>
+            <a:r>
+              <a:rPr lang="en-GB" sz="1800" dirty="0" err="1">
+                <a:effectLst/>
+                <a:latin typeface="JetBrains Mono"/>
+              </a:rPr>
+              <a:t>R.bIsVisible</a:t>
+            </a:r>
+            <a:r>
+              <a:rPr lang="en-GB" sz="1800" dirty="0">
+                <a:effectLst/>
+                <a:latin typeface="JetBrains Mono"/>
+              </a:rPr>
+              <a:t> &amp;&amp; (</a:t>
+            </a:r>
+            <a:r>
+              <a:rPr lang="en-GB" sz="1800" dirty="0" err="1">
+                <a:effectLst/>
+                <a:latin typeface="JetBrains Mono"/>
+              </a:rPr>
+              <a:t>TimeNow</a:t>
+            </a:r>
+            <a:r>
+              <a:rPr lang="en-GB" sz="1800" dirty="0">
+                <a:effectLst/>
+                <a:latin typeface="JetBrains Mono"/>
+              </a:rPr>
+              <a:t> - </a:t>
+            </a:r>
+            <a:r>
+              <a:rPr lang="en-GB" sz="1800" dirty="0" err="1">
+                <a:effectLst/>
+                <a:latin typeface="JetBrains Mono"/>
+              </a:rPr>
+              <a:t>R.LastSeenTime</a:t>
+            </a:r>
+            <a:r>
+              <a:rPr lang="en-GB" sz="1800" dirty="0">
+                <a:effectLst/>
+                <a:latin typeface="JetBrains Mono"/>
+              </a:rPr>
+              <a:t>) &gt; </a:t>
+            </a:r>
+            <a:r>
+              <a:rPr lang="en-GB" sz="1800" dirty="0" err="1">
+                <a:effectLst/>
+                <a:latin typeface="JetBrains Mono"/>
+              </a:rPr>
+              <a:t>ThreatMemoryDuration</a:t>
+            </a:r>
+            <a:r>
+              <a:rPr lang="en-GB" sz="1800" dirty="0">
+                <a:effectLst/>
+                <a:latin typeface="JetBrains Mono"/>
+              </a:rPr>
+              <a:t>);</a:t>
+            </a:r>
+            <a:br>
+              <a:rPr lang="en-GB" sz="1800" dirty="0">
+                <a:effectLst/>
+                <a:latin typeface="JetBrains Mono"/>
+              </a:rPr>
+            </a:br>
+            <a:r>
+              <a:rPr lang="en-GB" sz="1800" dirty="0">
+                <a:effectLst/>
+                <a:latin typeface="JetBrains Mono"/>
+              </a:rPr>
+              <a:t>});</a:t>
+            </a:r>
           </a:p>
         </p:txBody>
       </p:sp>
@@ -4254,6 +4706,122 @@
               <a:buNone/>
             </a:pPr>
             <a:endParaRPr lang="en-BE" dirty="0"/>
+          </a:p>
+        </p:txBody>
+      </p:sp>
+      <p:sp>
+        <p:nvSpPr>
+          <p:cNvPr id="4" name="TextBox 3">
+            <a:extLst>
+              <a:ext uri="{FF2B5EF4-FFF2-40B4-BE49-F238E27FC236}">
+                <a16:creationId xmlns:a16="http://schemas.microsoft.com/office/drawing/2014/main" id="{9313C08B-A0CE-CE58-9502-6C506F51C298}"/>
+              </a:ext>
+            </a:extLst>
+          </p:cNvPr>
+          <p:cNvSpPr txBox="1"/>
+          <p:nvPr/>
+        </p:nvSpPr>
+        <p:spPr>
+          <a:xfrm>
+            <a:off x="7990261" y="595281"/>
+            <a:ext cx="3166648" cy="954107"/>
+          </a:xfrm>
+          <a:prstGeom prst="rect">
+            <a:avLst/>
+          </a:prstGeom>
+          <a:noFill/>
+        </p:spPr>
+        <p:txBody>
+          <a:bodyPr wrap="square" rtlCol="0">
+            <a:spAutoFit/>
+          </a:bodyPr>
+          <a:lstStyle/>
+          <a:p>
+            <a:r>
+              <a:rPr lang="en-GB" sz="1400" i="1" dirty="0"/>
+              <a:t>// ----- Hardest Logic of the class -----</a:t>
+            </a:r>
+            <a:br>
+              <a:rPr lang="en-GB" sz="1400" i="1" dirty="0"/>
+            </a:br>
+            <a:r>
+              <a:rPr lang="en-GB" sz="1400" dirty="0" err="1"/>
+              <a:t>AActor</a:t>
+            </a:r>
+            <a:r>
+              <a:rPr lang="en-GB" sz="1400" dirty="0"/>
+              <a:t>* </a:t>
+            </a:r>
+            <a:r>
+              <a:rPr lang="en-GB" sz="1400" dirty="0" err="1"/>
+              <a:t>SelectThreat</a:t>
+            </a:r>
+            <a:r>
+              <a:rPr lang="en-GB" sz="1400" dirty="0"/>
+              <a:t>() </a:t>
+            </a:r>
+            <a:r>
+              <a:rPr lang="en-GB" sz="1400" dirty="0" err="1"/>
+              <a:t>const</a:t>
+            </a:r>
+            <a:r>
+              <a:rPr lang="en-GB" sz="1400" dirty="0"/>
+              <a:t>; </a:t>
+            </a:r>
+          </a:p>
+          <a:p>
+            <a:r>
+              <a:rPr lang="en-GB" sz="1400" dirty="0" err="1"/>
+              <a:t>AActor</a:t>
+            </a:r>
+            <a:r>
+              <a:rPr lang="en-GB" sz="1400" dirty="0"/>
+              <a:t>* </a:t>
+            </a:r>
+            <a:r>
+              <a:rPr lang="en-GB" sz="1400" dirty="0" err="1"/>
+              <a:t>SelectTargetItem</a:t>
+            </a:r>
+            <a:r>
+              <a:rPr lang="en-GB" sz="1400" dirty="0"/>
+              <a:t>() </a:t>
+            </a:r>
+            <a:r>
+              <a:rPr lang="en-GB" sz="1400" dirty="0" err="1"/>
+              <a:t>const</a:t>
+            </a:r>
+            <a:r>
+              <a:rPr lang="en-GB" sz="1400" dirty="0"/>
+              <a:t>;</a:t>
+            </a:r>
+            <a:br>
+              <a:rPr lang="en-GB" sz="1400" i="1" dirty="0"/>
+            </a:br>
+            <a:r>
+              <a:rPr lang="en-GB" sz="1400" dirty="0" err="1"/>
+              <a:t>AActor</a:t>
+            </a:r>
+            <a:r>
+              <a:rPr lang="en-GB" sz="1400" dirty="0"/>
+              <a:t>* </a:t>
+            </a:r>
+            <a:r>
+              <a:rPr lang="en-GB" sz="1400" dirty="0" err="1"/>
+              <a:t>SelectHouseTarget</a:t>
+            </a:r>
+            <a:r>
+              <a:rPr lang="en-GB" sz="1400" dirty="0"/>
+              <a:t>() </a:t>
+            </a:r>
+            <a:r>
+              <a:rPr lang="en-GB" sz="1400" dirty="0" err="1"/>
+              <a:t>const</a:t>
+            </a:r>
+            <a:r>
+              <a:rPr lang="en-GB" sz="1400" dirty="0"/>
+              <a:t>;</a:t>
+            </a:r>
+            <a:endParaRPr lang="LID4096" sz="1400" dirty="0"/>
           </a:p>
         </p:txBody>
       </p:sp>
@@ -4669,18 +5237,12 @@
 </file>
 
 <file path=customXml/item1.xml><?xml version="1.0" encoding="utf-8"?>
-<p:properties xmlns:p="http://schemas.microsoft.com/office/2006/metadata/properties" xmlns:xsi="http://www.w3.org/2001/XMLSchema-instance" xmlns:pc="http://schemas.microsoft.com/office/infopath/2007/PartnerControls">
-  <documentManagement>
-    <IconOverlay xmlns="http://schemas.microsoft.com/sharepoint/v4" xsi:nil="true"/>
-    <TaxCatchAll xmlns="128482ec-0431-40d5-ab26-89ea2a4f3ccd" xsi:nil="true"/>
-    <m99485b88215436a82099f8287cba0b0 xmlns="128482ec-0431-40d5-ab26-89ea2a4f3ccd">
-      <Terms xmlns="http://schemas.microsoft.com/office/infopath/2007/PartnerControls"/>
-    </m99485b88215436a82099f8287cba0b0>
-    <lcf76f155ced4ddcb4097134ff3c332f xmlns="60eb0cf4-ae2a-4762-800a-cb593b869ecb">
-      <Terms xmlns="http://schemas.microsoft.com/office/infopath/2007/PartnerControls"/>
-    </lcf76f155ced4ddcb4097134ff3c332f>
-  </documentManagement>
-</p:properties>
+<?mso-contentType ?>
+<FormTemplates xmlns="http://schemas.microsoft.com/sharepoint/v3/contenttype/forms">
+  <Display>DocumentLibraryForm</Display>
+  <Edit>DocumentLibraryForm</Edit>
+  <New>DocumentLibraryForm</New>
+</FormTemplates>
 </file>
 
 <file path=customXml/item2.xml><?xml version="1.0" encoding="utf-8"?>
@@ -4957,22 +5519,24 @@
 </file>
 
 <file path=customXml/item3.xml><?xml version="1.0" encoding="utf-8"?>
-<?mso-contentType ?>
-<FormTemplates xmlns="http://schemas.microsoft.com/sharepoint/v3/contenttype/forms">
-  <Display>DocumentLibraryForm</Display>
-  <Edit>DocumentLibraryForm</Edit>
-  <New>DocumentLibraryForm</New>
-</FormTemplates>
+<p:properties xmlns:p="http://schemas.microsoft.com/office/2006/metadata/properties" xmlns:xsi="http://www.w3.org/2001/XMLSchema-instance" xmlns:pc="http://schemas.microsoft.com/office/infopath/2007/PartnerControls">
+  <documentManagement>
+    <IconOverlay xmlns="http://schemas.microsoft.com/sharepoint/v4" xsi:nil="true"/>
+    <TaxCatchAll xmlns="128482ec-0431-40d5-ab26-89ea2a4f3ccd" xsi:nil="true"/>
+    <m99485b88215436a82099f8287cba0b0 xmlns="128482ec-0431-40d5-ab26-89ea2a4f3ccd">
+      <Terms xmlns="http://schemas.microsoft.com/office/infopath/2007/PartnerControls"/>
+    </m99485b88215436a82099f8287cba0b0>
+    <lcf76f155ced4ddcb4097134ff3c332f xmlns="60eb0cf4-ae2a-4762-800a-cb593b869ecb">
+      <Terms xmlns="http://schemas.microsoft.com/office/infopath/2007/PartnerControls"/>
+    </lcf76f155ced4ddcb4097134ff3c332f>
+  </documentManagement>
+</p:properties>
 </file>
 
 <file path=customXml/itemProps1.xml><?xml version="1.0" encoding="utf-8"?>
-<ds:datastoreItem xmlns:ds="http://schemas.openxmlformats.org/officeDocument/2006/customXml" ds:itemID="{B743389A-7EE0-4951-8919-E91DD69E3687}">
+<ds:datastoreItem xmlns:ds="http://schemas.openxmlformats.org/officeDocument/2006/customXml" ds:itemID="{AF8EC6D1-CB19-4400-AD0A-0C75CD884AEA}">
   <ds:schemaRefs>
-    <ds:schemaRef ds:uri="128482ec-0431-40d5-ab26-89ea2a4f3ccd"/>
-    <ds:schemaRef ds:uri="http://schemas.microsoft.com/office/2006/metadata/properties"/>
-    <ds:schemaRef ds:uri="http://schemas.microsoft.com/office/infopath/2007/PartnerControls"/>
-    <ds:schemaRef ds:uri="http://schemas.microsoft.com/sharepoint/v4"/>
-    <ds:schemaRef ds:uri="60eb0cf4-ae2a-4762-800a-cb593b869ecb"/>
+    <ds:schemaRef ds:uri="http://schemas.microsoft.com/sharepoint/v3/contenttype/forms"/>
   </ds:schemaRefs>
 </ds:datastoreItem>
 </file>
@@ -4999,9 +5563,13 @@
 </file>
 
 <file path=customXml/itemProps3.xml><?xml version="1.0" encoding="utf-8"?>
-<ds:datastoreItem xmlns:ds="http://schemas.openxmlformats.org/officeDocument/2006/customXml" ds:itemID="{AF8EC6D1-CB19-4400-AD0A-0C75CD884AEA}">
+<ds:datastoreItem xmlns:ds="http://schemas.openxmlformats.org/officeDocument/2006/customXml" ds:itemID="{B743389A-7EE0-4951-8919-E91DD69E3687}">
   <ds:schemaRefs>
-    <ds:schemaRef ds:uri="http://schemas.microsoft.com/sharepoint/v3/contenttype/forms"/>
+    <ds:schemaRef ds:uri="128482ec-0431-40d5-ab26-89ea2a4f3ccd"/>
+    <ds:schemaRef ds:uri="http://schemas.microsoft.com/office/2006/metadata/properties"/>
+    <ds:schemaRef ds:uri="http://schemas.microsoft.com/office/infopath/2007/PartnerControls"/>
+    <ds:schemaRef ds:uri="http://schemas.microsoft.com/sharepoint/v4"/>
+    <ds:schemaRef ds:uri="60eb0cf4-ae2a-4762-800a-cb593b869ecb"/>
   </ds:schemaRefs>
 </ds:datastoreItem>
 </file>
</xml_diff>

<commit_message>
Steering Behaviours - Reused + new MakeState / Apply
Added Seek, Flee, Face, Pursuit, Evade behaviour from before.
-------------------------------------
MakeState generates the FSteeringState struct with updated Pawn data - velocity, forward, location and potentially speed.
-------------------------------------
The new Apply method acts as the SetSteeringBehaviour from the old SteeringAgent class - it AddsMovementInput and Sets Actor Rotation depending on the passed parameter Steering Output.
</commit_message>
<xml_diff>
--- a/GPP_ZombieAI_AdamovDaniel_2DAE10.pptx
+++ b/GPP_ZombieAI_AdamovDaniel_2DAE10.pptx
@@ -405,7 +405,7 @@
           <a:p>
             <a:fld id="{82085877-2B37-48E7-8B6D-4D4ED486130A}" type="datetimeFigureOut">
               <a:rPr lang="en-BE" smtClean="0"/>
-              <a:t>05/31/2026</a:t>
+              <a:t>06/01/2026</a:t>
             </a:fld>
             <a:endParaRPr lang="en-BE"/>
           </a:p>
@@ -605,7 +605,7 @@
           <a:p>
             <a:fld id="{82085877-2B37-48E7-8B6D-4D4ED486130A}" type="datetimeFigureOut">
               <a:rPr lang="en-BE" smtClean="0"/>
-              <a:t>05/31/2026</a:t>
+              <a:t>06/01/2026</a:t>
             </a:fld>
             <a:endParaRPr lang="en-BE"/>
           </a:p>
@@ -815,7 +815,7 @@
           <a:p>
             <a:fld id="{82085877-2B37-48E7-8B6D-4D4ED486130A}" type="datetimeFigureOut">
               <a:rPr lang="en-BE" smtClean="0"/>
-              <a:t>05/31/2026</a:t>
+              <a:t>06/01/2026</a:t>
             </a:fld>
             <a:endParaRPr lang="en-BE"/>
           </a:p>
@@ -1015,7 +1015,7 @@
           <a:p>
             <a:fld id="{82085877-2B37-48E7-8B6D-4D4ED486130A}" type="datetimeFigureOut">
               <a:rPr lang="en-BE" smtClean="0"/>
-              <a:t>05/31/2026</a:t>
+              <a:t>06/01/2026</a:t>
             </a:fld>
             <a:endParaRPr lang="en-BE"/>
           </a:p>
@@ -1291,7 +1291,7 @@
           <a:p>
             <a:fld id="{82085877-2B37-48E7-8B6D-4D4ED486130A}" type="datetimeFigureOut">
               <a:rPr lang="en-BE" smtClean="0"/>
-              <a:t>05/31/2026</a:t>
+              <a:t>06/01/2026</a:t>
             </a:fld>
             <a:endParaRPr lang="en-BE"/>
           </a:p>
@@ -1559,7 +1559,7 @@
           <a:p>
             <a:fld id="{82085877-2B37-48E7-8B6D-4D4ED486130A}" type="datetimeFigureOut">
               <a:rPr lang="en-BE" smtClean="0"/>
-              <a:t>05/31/2026</a:t>
+              <a:t>06/01/2026</a:t>
             </a:fld>
             <a:endParaRPr lang="en-BE"/>
           </a:p>
@@ -1974,7 +1974,7 @@
           <a:p>
             <a:fld id="{82085877-2B37-48E7-8B6D-4D4ED486130A}" type="datetimeFigureOut">
               <a:rPr lang="en-BE" smtClean="0"/>
-              <a:t>05/31/2026</a:t>
+              <a:t>06/01/2026</a:t>
             </a:fld>
             <a:endParaRPr lang="en-BE"/>
           </a:p>
@@ -2116,7 +2116,7 @@
           <a:p>
             <a:fld id="{82085877-2B37-48E7-8B6D-4D4ED486130A}" type="datetimeFigureOut">
               <a:rPr lang="en-BE" smtClean="0"/>
-              <a:t>05/31/2026</a:t>
+              <a:t>06/01/2026</a:t>
             </a:fld>
             <a:endParaRPr lang="en-BE"/>
           </a:p>
@@ -2229,7 +2229,7 @@
           <a:p>
             <a:fld id="{82085877-2B37-48E7-8B6D-4D4ED486130A}" type="datetimeFigureOut">
               <a:rPr lang="en-BE" smtClean="0"/>
-              <a:t>05/31/2026</a:t>
+              <a:t>06/01/2026</a:t>
             </a:fld>
             <a:endParaRPr lang="en-BE"/>
           </a:p>
@@ -2542,7 +2542,7 @@
           <a:p>
             <a:fld id="{82085877-2B37-48E7-8B6D-4D4ED486130A}" type="datetimeFigureOut">
               <a:rPr lang="en-BE" smtClean="0"/>
-              <a:t>05/31/2026</a:t>
+              <a:t>06/01/2026</a:t>
             </a:fld>
             <a:endParaRPr lang="en-BE"/>
           </a:p>
@@ -2831,7 +2831,7 @@
           <a:p>
             <a:fld id="{82085877-2B37-48E7-8B6D-4D4ED486130A}" type="datetimeFigureOut">
               <a:rPr lang="en-BE" smtClean="0"/>
-              <a:t>05/31/2026</a:t>
+              <a:t>06/01/2026</a:t>
             </a:fld>
             <a:endParaRPr lang="en-BE"/>
           </a:p>
@@ -3074,7 +3074,7 @@
           <a:p>
             <a:fld id="{82085877-2B37-48E7-8B6D-4D4ED486130A}" type="datetimeFigureOut">
               <a:rPr lang="en-BE" smtClean="0"/>
-              <a:t>05/31/2026</a:t>
+              <a:t>06/01/2026</a:t>
             </a:fld>
             <a:endParaRPr lang="en-BE"/>
           </a:p>
@@ -4825,6 +4825,73 @@
           </a:p>
         </p:txBody>
       </p:sp>
+      <p:sp>
+        <p:nvSpPr>
+          <p:cNvPr id="6" name="TextBox 5">
+            <a:extLst>
+              <a:ext uri="{FF2B5EF4-FFF2-40B4-BE49-F238E27FC236}">
+                <a16:creationId xmlns:a16="http://schemas.microsoft.com/office/drawing/2014/main" id="{4F87ED8C-910F-DA03-47CA-72F93D9CBA04}"/>
+              </a:ext>
+            </a:extLst>
+          </p:cNvPr>
+          <p:cNvSpPr txBox="1"/>
+          <p:nvPr/>
+        </p:nvSpPr>
+        <p:spPr>
+          <a:xfrm>
+            <a:off x="5724206" y="4834572"/>
+            <a:ext cx="6097022" cy="1477328"/>
+          </a:xfrm>
+          <a:prstGeom prst="rect">
+            <a:avLst/>
+          </a:prstGeom>
+          <a:noFill/>
+        </p:spPr>
+        <p:txBody>
+          <a:bodyPr wrap="square">
+            <a:spAutoFit/>
+          </a:bodyPr>
+          <a:lstStyle/>
+          <a:p>
+            <a:r>
+              <a:rPr lang="en-GB" b="0" i="0" dirty="0">
+                <a:effectLst/>
+                <a:latin typeface="SFMono-Regular"/>
+              </a:rPr>
+              <a:t>The survivor would often get stuck in the visited house range AFTER </a:t>
+            </a:r>
+            <a:r>
+              <a:rPr lang="en-GB" b="0" i="0" dirty="0" err="1">
+                <a:effectLst/>
+                <a:latin typeface="SFMono-Regular"/>
+              </a:rPr>
+              <a:t>MoveTo</a:t>
+            </a:r>
+            <a:r>
+              <a:rPr lang="en-GB" b="0" i="0" dirty="0">
+                <a:effectLst/>
+                <a:latin typeface="SFMono-Regular"/>
+              </a:rPr>
+              <a:t> has already returned succeeded for the </a:t>
+            </a:r>
+            <a:r>
+              <a:rPr lang="en-GB" b="0" i="0" dirty="0" err="1">
+                <a:effectLst/>
+                <a:latin typeface="SFMono-Regular"/>
+              </a:rPr>
+              <a:t>InvestigateHouse</a:t>
+            </a:r>
+            <a:r>
+              <a:rPr lang="en-GB" b="0" i="0" dirty="0">
+                <a:effectLst/>
+                <a:latin typeface="SFMono-Regular"/>
+              </a:rPr>
+              <a:t> sequence. This made the survivor stuck infinitely. Now a Stuck Check is added with an interval that marks the investigated house as visited and moves on.</a:t>
+            </a:r>
+            <a:endParaRPr lang="LID4096" dirty="0"/>
+          </a:p>
+        </p:txBody>
+      </p:sp>
     </p:spTree>
     <p:extLst>
       <p:ext uri="{BB962C8B-B14F-4D97-AF65-F5344CB8AC3E}">
@@ -5237,12 +5304,18 @@
 </file>
 
 <file path=customXml/item1.xml><?xml version="1.0" encoding="utf-8"?>
-<?mso-contentType ?>
-<FormTemplates xmlns="http://schemas.microsoft.com/sharepoint/v3/contenttype/forms">
-  <Display>DocumentLibraryForm</Display>
-  <Edit>DocumentLibraryForm</Edit>
-  <New>DocumentLibraryForm</New>
-</FormTemplates>
+<p:properties xmlns:p="http://schemas.microsoft.com/office/2006/metadata/properties" xmlns:xsi="http://www.w3.org/2001/XMLSchema-instance" xmlns:pc="http://schemas.microsoft.com/office/infopath/2007/PartnerControls">
+  <documentManagement>
+    <IconOverlay xmlns="http://schemas.microsoft.com/sharepoint/v4" xsi:nil="true"/>
+    <TaxCatchAll xmlns="128482ec-0431-40d5-ab26-89ea2a4f3ccd" xsi:nil="true"/>
+    <m99485b88215436a82099f8287cba0b0 xmlns="128482ec-0431-40d5-ab26-89ea2a4f3ccd">
+      <Terms xmlns="http://schemas.microsoft.com/office/infopath/2007/PartnerControls"/>
+    </m99485b88215436a82099f8287cba0b0>
+    <lcf76f155ced4ddcb4097134ff3c332f xmlns="60eb0cf4-ae2a-4762-800a-cb593b869ecb">
+      <Terms xmlns="http://schemas.microsoft.com/office/infopath/2007/PartnerControls"/>
+    </lcf76f155ced4ddcb4097134ff3c332f>
+  </documentManagement>
+</p:properties>
 </file>
 
 <file path=customXml/item2.xml><?xml version="1.0" encoding="utf-8"?>
@@ -5519,24 +5592,22 @@
 </file>
 
 <file path=customXml/item3.xml><?xml version="1.0" encoding="utf-8"?>
-<p:properties xmlns:p="http://schemas.microsoft.com/office/2006/metadata/properties" xmlns:xsi="http://www.w3.org/2001/XMLSchema-instance" xmlns:pc="http://schemas.microsoft.com/office/infopath/2007/PartnerControls">
-  <documentManagement>
-    <IconOverlay xmlns="http://schemas.microsoft.com/sharepoint/v4" xsi:nil="true"/>
-    <TaxCatchAll xmlns="128482ec-0431-40d5-ab26-89ea2a4f3ccd" xsi:nil="true"/>
-    <m99485b88215436a82099f8287cba0b0 xmlns="128482ec-0431-40d5-ab26-89ea2a4f3ccd">
-      <Terms xmlns="http://schemas.microsoft.com/office/infopath/2007/PartnerControls"/>
-    </m99485b88215436a82099f8287cba0b0>
-    <lcf76f155ced4ddcb4097134ff3c332f xmlns="60eb0cf4-ae2a-4762-800a-cb593b869ecb">
-      <Terms xmlns="http://schemas.microsoft.com/office/infopath/2007/PartnerControls"/>
-    </lcf76f155ced4ddcb4097134ff3c332f>
-  </documentManagement>
-</p:properties>
+<?mso-contentType ?>
+<FormTemplates xmlns="http://schemas.microsoft.com/sharepoint/v3/contenttype/forms">
+  <Display>DocumentLibraryForm</Display>
+  <Edit>DocumentLibraryForm</Edit>
+  <New>DocumentLibraryForm</New>
+</FormTemplates>
 </file>
 
 <file path=customXml/itemProps1.xml><?xml version="1.0" encoding="utf-8"?>
-<ds:datastoreItem xmlns:ds="http://schemas.openxmlformats.org/officeDocument/2006/customXml" ds:itemID="{AF8EC6D1-CB19-4400-AD0A-0C75CD884AEA}">
+<ds:datastoreItem xmlns:ds="http://schemas.openxmlformats.org/officeDocument/2006/customXml" ds:itemID="{B743389A-7EE0-4951-8919-E91DD69E3687}">
   <ds:schemaRefs>
-    <ds:schemaRef ds:uri="http://schemas.microsoft.com/sharepoint/v3/contenttype/forms"/>
+    <ds:schemaRef ds:uri="128482ec-0431-40d5-ab26-89ea2a4f3ccd"/>
+    <ds:schemaRef ds:uri="http://schemas.microsoft.com/office/2006/metadata/properties"/>
+    <ds:schemaRef ds:uri="http://schemas.microsoft.com/office/infopath/2007/PartnerControls"/>
+    <ds:schemaRef ds:uri="http://schemas.microsoft.com/sharepoint/v4"/>
+    <ds:schemaRef ds:uri="60eb0cf4-ae2a-4762-800a-cb593b869ecb"/>
   </ds:schemaRefs>
 </ds:datastoreItem>
 </file>
@@ -5563,13 +5634,9 @@
 </file>
 
 <file path=customXml/itemProps3.xml><?xml version="1.0" encoding="utf-8"?>
-<ds:datastoreItem xmlns:ds="http://schemas.openxmlformats.org/officeDocument/2006/customXml" ds:itemID="{B743389A-7EE0-4951-8919-E91DD69E3687}">
+<ds:datastoreItem xmlns:ds="http://schemas.openxmlformats.org/officeDocument/2006/customXml" ds:itemID="{AF8EC6D1-CB19-4400-AD0A-0C75CD884AEA}">
   <ds:schemaRefs>
-    <ds:schemaRef ds:uri="128482ec-0431-40d5-ab26-89ea2a4f3ccd"/>
-    <ds:schemaRef ds:uri="http://schemas.microsoft.com/office/2006/metadata/properties"/>
-    <ds:schemaRef ds:uri="http://schemas.microsoft.com/office/infopath/2007/PartnerControls"/>
-    <ds:schemaRef ds:uri="http://schemas.microsoft.com/sharepoint/v4"/>
-    <ds:schemaRef ds:uri="60eb0cf4-ae2a-4762-800a-cb593b869ecb"/>
+    <ds:schemaRef ds:uri="http://schemas.microsoft.com/sharepoint/v3/contenttype/forms"/>
   </ds:schemaRefs>
 </ds:datastoreItem>
 </file>
</xml_diff>

<commit_message>
FSM wired up in Combat Task
FSM Instance is Built and Started in the Task Enter.
FSM Instance is Ticked in Task Tick.
FSM Instance is stopped in Task Abort and Task End.
-------------------------------------
Combat States are assigned Transitions which constantly check the distance between Survivor and Threat.
</commit_message>
<xml_diff>
--- a/GPP_ZombieAI_AdamovDaniel_2DAE10.pptx
+++ b/GPP_ZombieAI_AdamovDaniel_2DAE10.pptx
@@ -3738,10 +3738,10 @@
           <a:lstStyle/>
           <a:p>
             <a:r>
-              <a:rPr lang="en-US"/>
+              <a:rPr lang="en-US" dirty="0"/>
               <a:t>Enemy handling</a:t>
             </a:r>
-            <a:endParaRPr lang="en-BE"/>
+            <a:endParaRPr lang="en-BE" dirty="0"/>
           </a:p>
         </p:txBody>
       </p:sp>
@@ -3767,7 +3767,7 @@
           <a:lstStyle/>
           <a:p>
             <a:r>
-              <a:rPr lang="en-US" i="1">
+              <a:rPr lang="en-US" i="1" dirty="0">
                 <a:solidFill>
                   <a:schemeClr val="bg1">
                     <a:lumMod val="75000"/>
@@ -3776,7 +3776,7 @@
               </a:rPr>
               <a:t>How does your agent deal with enemies (aiming, shooting, item usage, avoidance, hiding, usage of sprint, …)?</a:t>
             </a:r>
-            <a:endParaRPr lang="en-BE" i="1">
+            <a:endParaRPr lang="en-BE" i="1" dirty="0">
               <a:solidFill>
                 <a:schemeClr val="bg1">
                   <a:lumMod val="75000"/>
@@ -3786,7 +3786,7 @@
           </a:p>
           <a:p>
             <a:r>
-              <a:rPr lang="en-US" i="1">
+              <a:rPr lang="en-US" i="1" dirty="0">
                 <a:solidFill>
                   <a:schemeClr val="bg1">
                     <a:lumMod val="75000"/>
@@ -3795,7 +3795,164 @@
               </a:rPr>
               <a:t>USE IMAGES/GIFS</a:t>
             </a:r>
-            <a:endParaRPr lang="en-BE"/>
+          </a:p>
+          <a:p>
+            <a:endParaRPr lang="en-US" i="1" dirty="0">
+              <a:solidFill>
+                <a:schemeClr val="bg1">
+                  <a:lumMod val="75000"/>
+                </a:schemeClr>
+              </a:solidFill>
+            </a:endParaRPr>
+          </a:p>
+          <a:p>
+            <a:pPr marL="0" indent="0">
+              <a:buNone/>
+            </a:pPr>
+            <a:endParaRPr lang="en-US" i="1" dirty="0">
+              <a:solidFill>
+                <a:schemeClr val="bg1">
+                  <a:lumMod val="75000"/>
+                </a:schemeClr>
+              </a:solidFill>
+            </a:endParaRPr>
+          </a:p>
+        </p:txBody>
+      </p:sp>
+      <p:sp>
+        <p:nvSpPr>
+          <p:cNvPr id="4" name="TextBox 3">
+            <a:extLst>
+              <a:ext uri="{FF2B5EF4-FFF2-40B4-BE49-F238E27FC236}">
+                <a16:creationId xmlns:a16="http://schemas.microsoft.com/office/drawing/2014/main" id="{18FA1107-B0DD-445B-EB4B-A1EF37F4EB91}"/>
+              </a:ext>
+            </a:extLst>
+          </p:cNvPr>
+          <p:cNvSpPr txBox="1"/>
+          <p:nvPr/>
+        </p:nvSpPr>
+        <p:spPr>
+          <a:xfrm>
+            <a:off x="730293" y="3479630"/>
+            <a:ext cx="8665320" cy="923330"/>
+          </a:xfrm>
+          <a:prstGeom prst="rect">
+            <a:avLst/>
+          </a:prstGeom>
+          <a:noFill/>
+        </p:spPr>
+        <p:txBody>
+          <a:bodyPr wrap="square" rtlCol="0">
+            <a:spAutoFit/>
+          </a:bodyPr>
+          <a:lstStyle/>
+          <a:p>
+            <a:r>
+              <a:rPr lang="en-GB" dirty="0"/>
+              <a:t>Weapons fire along the forward vector, zombies need to be “faced” so we use the FACE steering Behaviour.</a:t>
+            </a:r>
+          </a:p>
+          <a:p>
+            <a:r>
+              <a:rPr lang="en-GB" dirty="0"/>
+              <a:t>Evade/Flee will also be useful for close range kiting.</a:t>
+            </a:r>
+            <a:endParaRPr lang="LID4096" dirty="0"/>
+          </a:p>
+        </p:txBody>
+      </p:sp>
+      <p:sp>
+        <p:nvSpPr>
+          <p:cNvPr id="6" name="TextBox 5">
+            <a:extLst>
+              <a:ext uri="{FF2B5EF4-FFF2-40B4-BE49-F238E27FC236}">
+                <a16:creationId xmlns:a16="http://schemas.microsoft.com/office/drawing/2014/main" id="{D7564C4A-320B-31A3-68E5-3844BD49CF61}"/>
+              </a:ext>
+            </a:extLst>
+          </p:cNvPr>
+          <p:cNvSpPr txBox="1"/>
+          <p:nvPr/>
+        </p:nvSpPr>
+        <p:spPr>
+          <a:xfrm>
+            <a:off x="1219712" y="4828296"/>
+            <a:ext cx="6097022" cy="646331"/>
+          </a:xfrm>
+          <a:prstGeom prst="rect">
+            <a:avLst/>
+          </a:prstGeom>
+          <a:noFill/>
+        </p:spPr>
+        <p:txBody>
+          <a:bodyPr wrap="square">
+            <a:spAutoFit/>
+          </a:bodyPr>
+          <a:lstStyle/>
+          <a:p>
+            <a:r>
+              <a:rPr lang="en-GB" dirty="0"/>
+              <a:t>FSM is the perfect fit for Aim and Fire + back off when cornered + re-aim when zombie moves combat logic!</a:t>
+            </a:r>
+            <a:endParaRPr lang="LID4096" dirty="0"/>
+          </a:p>
+        </p:txBody>
+      </p:sp>
+      <p:sp>
+        <p:nvSpPr>
+          <p:cNvPr id="8" name="TextBox 7">
+            <a:extLst>
+              <a:ext uri="{FF2B5EF4-FFF2-40B4-BE49-F238E27FC236}">
+                <a16:creationId xmlns:a16="http://schemas.microsoft.com/office/drawing/2014/main" id="{17EE9F25-7D4F-5BED-CF2E-916834DA9E2F}"/>
+              </a:ext>
+            </a:extLst>
+          </p:cNvPr>
+          <p:cNvSpPr txBox="1"/>
+          <p:nvPr/>
+        </p:nvSpPr>
+        <p:spPr>
+          <a:xfrm>
+            <a:off x="5736480" y="21139"/>
+            <a:ext cx="6097022" cy="1754326"/>
+          </a:xfrm>
+          <a:prstGeom prst="rect">
+            <a:avLst/>
+          </a:prstGeom>
+          <a:noFill/>
+        </p:spPr>
+        <p:txBody>
+          <a:bodyPr wrap="square">
+            <a:spAutoFit/>
+          </a:bodyPr>
+          <a:lstStyle/>
+          <a:p>
+            <a:r>
+              <a:rPr lang="LID4096" dirty="0"/>
+              <a:t>FSM Instance is Built and Started in the Task Enter.</a:t>
+            </a:r>
+          </a:p>
+          <a:p>
+            <a:r>
+              <a:rPr lang="LID4096" dirty="0"/>
+              <a:t>FSM Instance is Ticked in Task Tick.</a:t>
+            </a:r>
+          </a:p>
+          <a:p>
+            <a:r>
+              <a:rPr lang="LID4096" dirty="0"/>
+              <a:t>FSM Instance is stopped in Task Abort and Task End.</a:t>
+            </a:r>
+          </a:p>
+          <a:p>
+            <a:r>
+              <a:rPr lang="LID4096" dirty="0"/>
+              <a:t>-------------------------------------</a:t>
+            </a:r>
+          </a:p>
+          <a:p>
+            <a:r>
+              <a:rPr lang="LID4096" dirty="0"/>
+              <a:t>Combat States are assigned Transitions which constantly check the distance between Survivor and Threat. </a:t>
+            </a:r>
           </a:p>
         </p:txBody>
       </p:sp>
@@ -5304,18 +5461,12 @@
 </file>
 
 <file path=customXml/item1.xml><?xml version="1.0" encoding="utf-8"?>
-<p:properties xmlns:p="http://schemas.microsoft.com/office/2006/metadata/properties" xmlns:xsi="http://www.w3.org/2001/XMLSchema-instance" xmlns:pc="http://schemas.microsoft.com/office/infopath/2007/PartnerControls">
-  <documentManagement>
-    <IconOverlay xmlns="http://schemas.microsoft.com/sharepoint/v4" xsi:nil="true"/>
-    <TaxCatchAll xmlns="128482ec-0431-40d5-ab26-89ea2a4f3ccd" xsi:nil="true"/>
-    <m99485b88215436a82099f8287cba0b0 xmlns="128482ec-0431-40d5-ab26-89ea2a4f3ccd">
-      <Terms xmlns="http://schemas.microsoft.com/office/infopath/2007/PartnerControls"/>
-    </m99485b88215436a82099f8287cba0b0>
-    <lcf76f155ced4ddcb4097134ff3c332f xmlns="60eb0cf4-ae2a-4762-800a-cb593b869ecb">
-      <Terms xmlns="http://schemas.microsoft.com/office/infopath/2007/PartnerControls"/>
-    </lcf76f155ced4ddcb4097134ff3c332f>
-  </documentManagement>
-</p:properties>
+<?mso-contentType ?>
+<FormTemplates xmlns="http://schemas.microsoft.com/sharepoint/v3/contenttype/forms">
+  <Display>DocumentLibraryForm</Display>
+  <Edit>DocumentLibraryForm</Edit>
+  <New>DocumentLibraryForm</New>
+</FormTemplates>
 </file>
 
 <file path=customXml/item2.xml><?xml version="1.0" encoding="utf-8"?>
@@ -5592,22 +5743,24 @@
 </file>
 
 <file path=customXml/item3.xml><?xml version="1.0" encoding="utf-8"?>
-<?mso-contentType ?>
-<FormTemplates xmlns="http://schemas.microsoft.com/sharepoint/v3/contenttype/forms">
-  <Display>DocumentLibraryForm</Display>
-  <Edit>DocumentLibraryForm</Edit>
-  <New>DocumentLibraryForm</New>
-</FormTemplates>
+<p:properties xmlns:p="http://schemas.microsoft.com/office/2006/metadata/properties" xmlns:xsi="http://www.w3.org/2001/XMLSchema-instance" xmlns:pc="http://schemas.microsoft.com/office/infopath/2007/PartnerControls">
+  <documentManagement>
+    <IconOverlay xmlns="http://schemas.microsoft.com/sharepoint/v4" xsi:nil="true"/>
+    <TaxCatchAll xmlns="128482ec-0431-40d5-ab26-89ea2a4f3ccd" xsi:nil="true"/>
+    <m99485b88215436a82099f8287cba0b0 xmlns="128482ec-0431-40d5-ab26-89ea2a4f3ccd">
+      <Terms xmlns="http://schemas.microsoft.com/office/infopath/2007/PartnerControls"/>
+    </m99485b88215436a82099f8287cba0b0>
+    <lcf76f155ced4ddcb4097134ff3c332f xmlns="60eb0cf4-ae2a-4762-800a-cb593b869ecb">
+      <Terms xmlns="http://schemas.microsoft.com/office/infopath/2007/PartnerControls"/>
+    </lcf76f155ced4ddcb4097134ff3c332f>
+  </documentManagement>
+</p:properties>
 </file>
 
 <file path=customXml/itemProps1.xml><?xml version="1.0" encoding="utf-8"?>
-<ds:datastoreItem xmlns:ds="http://schemas.openxmlformats.org/officeDocument/2006/customXml" ds:itemID="{B743389A-7EE0-4951-8919-E91DD69E3687}">
+<ds:datastoreItem xmlns:ds="http://schemas.openxmlformats.org/officeDocument/2006/customXml" ds:itemID="{AF8EC6D1-CB19-4400-AD0A-0C75CD884AEA}">
   <ds:schemaRefs>
-    <ds:schemaRef ds:uri="128482ec-0431-40d5-ab26-89ea2a4f3ccd"/>
-    <ds:schemaRef ds:uri="http://schemas.microsoft.com/office/2006/metadata/properties"/>
-    <ds:schemaRef ds:uri="http://schemas.microsoft.com/office/infopath/2007/PartnerControls"/>
-    <ds:schemaRef ds:uri="http://schemas.microsoft.com/sharepoint/v4"/>
-    <ds:schemaRef ds:uri="60eb0cf4-ae2a-4762-800a-cb593b869ecb"/>
+    <ds:schemaRef ds:uri="http://schemas.microsoft.com/sharepoint/v3/contenttype/forms"/>
   </ds:schemaRefs>
 </ds:datastoreItem>
 </file>
@@ -5634,9 +5787,13 @@
 </file>
 
 <file path=customXml/itemProps3.xml><?xml version="1.0" encoding="utf-8"?>
-<ds:datastoreItem xmlns:ds="http://schemas.openxmlformats.org/officeDocument/2006/customXml" ds:itemID="{AF8EC6D1-CB19-4400-AD0A-0C75CD884AEA}">
+<ds:datastoreItem xmlns:ds="http://schemas.openxmlformats.org/officeDocument/2006/customXml" ds:itemID="{B743389A-7EE0-4951-8919-E91DD69E3687}">
   <ds:schemaRefs>
-    <ds:schemaRef ds:uri="http://schemas.microsoft.com/sharepoint/v3/contenttype/forms"/>
+    <ds:schemaRef ds:uri="128482ec-0431-40d5-ab26-89ea2a4f3ccd"/>
+    <ds:schemaRef ds:uri="http://schemas.microsoft.com/office/2006/metadata/properties"/>
+    <ds:schemaRef ds:uri="http://schemas.microsoft.com/office/infopath/2007/PartnerControls"/>
+    <ds:schemaRef ds:uri="http://schemas.microsoft.com/sharepoint/v4"/>
+    <ds:schemaRef ds:uri="60eb0cf4-ae2a-4762-800a-cb593b869ecb"/>
   </ds:schemaRefs>
 </ds:datastoreItem>
 </file>
</xml_diff>

<commit_message>
Threat Speed and Near Count BB keys
Started implementing the Flee Task:
Two new BB keys are needed connected to Threat - Threat Speed and how many Threats are nearby.
-------------------------------------
They are calculated at the same point of the program as ThreatActor is set since it literally uses same actor as source for this info. This means this happens in Student Perceptor's WriteToBlackboard method.
</commit_message>
<xml_diff>
--- a/GPP_ZombieAI_AdamovDaniel_2DAE10.pptx
+++ b/GPP_ZombieAI_AdamovDaniel_2DAE10.pptx
@@ -3686,6 +3686,338 @@
           </a:p>
         </p:txBody>
       </p:sp>
+      <p:sp>
+        <p:nvSpPr>
+          <p:cNvPr id="7" name="TextBox 6">
+            <a:extLst>
+              <a:ext uri="{FF2B5EF4-FFF2-40B4-BE49-F238E27FC236}">
+                <a16:creationId xmlns:a16="http://schemas.microsoft.com/office/drawing/2014/main" id="{79A5084E-9CF4-3942-9685-4BF7B41998B1}"/>
+              </a:ext>
+            </a:extLst>
+          </p:cNvPr>
+          <p:cNvSpPr txBox="1"/>
+          <p:nvPr/>
+        </p:nvSpPr>
+        <p:spPr>
+          <a:xfrm>
+            <a:off x="6258118" y="2780021"/>
+            <a:ext cx="6097022" cy="2862322"/>
+          </a:xfrm>
+          <a:prstGeom prst="rect">
+            <a:avLst/>
+          </a:prstGeom>
+          <a:noFill/>
+        </p:spPr>
+        <p:txBody>
+          <a:bodyPr wrap="square">
+            <a:spAutoFit/>
+          </a:bodyPr>
+          <a:lstStyle/>
+          <a:p>
+            <a:pPr>
+              <a:buNone/>
+            </a:pPr>
+            <a:r>
+              <a:rPr lang="en-GB" dirty="0">
+                <a:latin typeface="JetBrains Mono"/>
+              </a:rPr>
+              <a:t>Memory c</a:t>
+            </a:r>
+            <a:r>
+              <a:rPr lang="en-GB" sz="1800" dirty="0">
+                <a:effectLst/>
+                <a:latin typeface="JetBrains Mono"/>
+              </a:rPr>
+              <a:t>ompared to Zombies:</a:t>
+            </a:r>
+          </a:p>
+          <a:p>
+            <a:pPr>
+              <a:buNone/>
+            </a:pPr>
+            <a:r>
+              <a:rPr lang="en-GB" sz="1800" dirty="0" err="1">
+                <a:effectLst/>
+                <a:latin typeface="JetBrains Mono"/>
+              </a:rPr>
+              <a:t>Items.RemoveAll</a:t>
+            </a:r>
+            <a:r>
+              <a:rPr lang="en-GB" sz="1800" dirty="0">
+                <a:effectLst/>
+                <a:latin typeface="JetBrains Mono"/>
+              </a:rPr>
+              <a:t>( [](</a:t>
+            </a:r>
+            <a:r>
+              <a:rPr lang="en-GB" sz="1800" dirty="0" err="1">
+                <a:effectLst/>
+                <a:latin typeface="JetBrains Mono"/>
+              </a:rPr>
+              <a:t>const</a:t>
+            </a:r>
+            <a:r>
+              <a:rPr lang="en-GB" sz="1800" dirty="0">
+                <a:effectLst/>
+                <a:latin typeface="JetBrains Mono"/>
+              </a:rPr>
+              <a:t> </a:t>
+            </a:r>
+            <a:r>
+              <a:rPr lang="en-GB" sz="1800" dirty="0" err="1">
+                <a:effectLst/>
+                <a:latin typeface="JetBrains Mono"/>
+              </a:rPr>
+              <a:t>FPerceivedItem</a:t>
+            </a:r>
+            <a:r>
+              <a:rPr lang="en-GB" sz="1800" dirty="0">
+                <a:effectLst/>
+                <a:latin typeface="JetBrains Mono"/>
+              </a:rPr>
+              <a:t>&amp; R)</a:t>
+            </a:r>
+            <a:br>
+              <a:rPr lang="en-GB" sz="1800" dirty="0">
+                <a:effectLst/>
+                <a:latin typeface="JetBrains Mono"/>
+              </a:rPr>
+            </a:br>
+            <a:r>
+              <a:rPr lang="en-GB" sz="1800" dirty="0">
+                <a:effectLst/>
+                <a:latin typeface="JetBrains Mono"/>
+              </a:rPr>
+              <a:t>{</a:t>
+            </a:r>
+            <a:br>
+              <a:rPr lang="en-GB" sz="1800" dirty="0">
+                <a:effectLst/>
+                <a:latin typeface="JetBrains Mono"/>
+              </a:rPr>
+            </a:br>
+            <a:r>
+              <a:rPr lang="en-GB" sz="1800" dirty="0">
+                <a:effectLst/>
+                <a:latin typeface="JetBrains Mono"/>
+              </a:rPr>
+              <a:t>    return !</a:t>
+            </a:r>
+            <a:r>
+              <a:rPr lang="en-GB" sz="1800" dirty="0" err="1">
+                <a:effectLst/>
+                <a:latin typeface="JetBrains Mono"/>
+              </a:rPr>
+              <a:t>R.Actor.IsValid</a:t>
+            </a:r>
+            <a:r>
+              <a:rPr lang="en-GB" sz="1800" dirty="0">
+                <a:effectLst/>
+                <a:latin typeface="JetBrains Mono"/>
+              </a:rPr>
+              <a:t>() || </a:t>
+            </a:r>
+            <a:r>
+              <a:rPr lang="en-GB" sz="1800" dirty="0" err="1">
+                <a:effectLst/>
+                <a:latin typeface="JetBrains Mono"/>
+              </a:rPr>
+              <a:t>R.Actor</a:t>
+            </a:r>
+            <a:r>
+              <a:rPr lang="en-GB" sz="1800" dirty="0">
+                <a:effectLst/>
+                <a:latin typeface="JetBrains Mono"/>
+              </a:rPr>
+              <a:t>-&gt;</a:t>
+            </a:r>
+            <a:r>
+              <a:rPr lang="en-GB" sz="1800" dirty="0" err="1">
+                <a:effectLst/>
+                <a:latin typeface="JetBrains Mono"/>
+              </a:rPr>
+              <a:t>IsHidden</a:t>
+            </a:r>
+            <a:r>
+              <a:rPr lang="en-GB" sz="1800" dirty="0">
+                <a:effectLst/>
+                <a:latin typeface="JetBrains Mono"/>
+              </a:rPr>
+              <a:t>();</a:t>
+            </a:r>
+            <a:br>
+              <a:rPr lang="en-GB" sz="1800" dirty="0">
+                <a:effectLst/>
+                <a:latin typeface="JetBrains Mono"/>
+              </a:rPr>
+            </a:br>
+            <a:r>
+              <a:rPr lang="en-GB" sz="1800" dirty="0">
+                <a:effectLst/>
+                <a:latin typeface="JetBrains Mono"/>
+              </a:rPr>
+              <a:t>});</a:t>
+            </a:r>
+            <a:br>
+              <a:rPr lang="en-GB" sz="1800" dirty="0">
+                <a:effectLst/>
+                <a:latin typeface="JetBrains Mono"/>
+              </a:rPr>
+            </a:br>
+            <a:r>
+              <a:rPr lang="en-GB" sz="1800" dirty="0" err="1">
+                <a:effectLst/>
+                <a:latin typeface="JetBrains Mono"/>
+              </a:rPr>
+              <a:t>Zombies.RemoveAll</a:t>
+            </a:r>
+            <a:r>
+              <a:rPr lang="en-GB" sz="1800" dirty="0">
+                <a:effectLst/>
+                <a:latin typeface="JetBrains Mono"/>
+              </a:rPr>
+              <a:t>([&amp;](</a:t>
+            </a:r>
+            <a:r>
+              <a:rPr lang="en-GB" sz="1800" dirty="0" err="1">
+                <a:effectLst/>
+                <a:latin typeface="JetBrains Mono"/>
+              </a:rPr>
+              <a:t>const</a:t>
+            </a:r>
+            <a:r>
+              <a:rPr lang="en-GB" sz="1800" dirty="0">
+                <a:effectLst/>
+                <a:latin typeface="JetBrains Mono"/>
+              </a:rPr>
+              <a:t> </a:t>
+            </a:r>
+            <a:r>
+              <a:rPr lang="en-GB" sz="1800" dirty="0" err="1">
+                <a:effectLst/>
+                <a:latin typeface="JetBrains Mono"/>
+              </a:rPr>
+              <a:t>FPerceivedActor</a:t>
+            </a:r>
+            <a:r>
+              <a:rPr lang="en-GB" sz="1800" dirty="0">
+                <a:effectLst/>
+                <a:latin typeface="JetBrains Mono"/>
+              </a:rPr>
+              <a:t>&amp; R)</a:t>
+            </a:r>
+            <a:br>
+              <a:rPr lang="en-GB" sz="1800" dirty="0">
+                <a:effectLst/>
+                <a:latin typeface="JetBrains Mono"/>
+              </a:rPr>
+            </a:br>
+            <a:r>
+              <a:rPr lang="en-GB" sz="1800" dirty="0">
+                <a:effectLst/>
+                <a:latin typeface="JetBrains Mono"/>
+              </a:rPr>
+              <a:t>{</a:t>
+            </a:r>
+            <a:br>
+              <a:rPr lang="en-GB" sz="1800" dirty="0">
+                <a:effectLst/>
+                <a:latin typeface="JetBrains Mono"/>
+              </a:rPr>
+            </a:br>
+            <a:r>
+              <a:rPr lang="en-GB" sz="1800" dirty="0">
+                <a:effectLst/>
+                <a:latin typeface="JetBrains Mono"/>
+              </a:rPr>
+              <a:t>    return !</a:t>
+            </a:r>
+            <a:r>
+              <a:rPr lang="en-GB" sz="1800" dirty="0" err="1">
+                <a:effectLst/>
+                <a:latin typeface="JetBrains Mono"/>
+              </a:rPr>
+              <a:t>R.Actor.IsValid</a:t>
+            </a:r>
+            <a:r>
+              <a:rPr lang="en-GB" sz="1800" dirty="0">
+                <a:effectLst/>
+                <a:latin typeface="JetBrains Mono"/>
+              </a:rPr>
+              <a:t>() || (!</a:t>
+            </a:r>
+            <a:r>
+              <a:rPr lang="en-GB" sz="1800" dirty="0" err="1">
+                <a:effectLst/>
+                <a:latin typeface="JetBrains Mono"/>
+              </a:rPr>
+              <a:t>R.bIsVisible</a:t>
+            </a:r>
+            <a:r>
+              <a:rPr lang="en-GB" sz="1800" dirty="0">
+                <a:effectLst/>
+                <a:latin typeface="JetBrains Mono"/>
+              </a:rPr>
+              <a:t> &amp;&amp; (</a:t>
+            </a:r>
+            <a:r>
+              <a:rPr lang="en-GB" sz="1800" dirty="0" err="1">
+                <a:effectLst/>
+                <a:latin typeface="JetBrains Mono"/>
+              </a:rPr>
+              <a:t>TimeNow</a:t>
+            </a:r>
+            <a:r>
+              <a:rPr lang="en-GB" sz="1800" dirty="0">
+                <a:effectLst/>
+                <a:latin typeface="JetBrains Mono"/>
+              </a:rPr>
+              <a:t> - </a:t>
+            </a:r>
+            <a:r>
+              <a:rPr lang="en-GB" sz="1800" dirty="0" err="1">
+                <a:effectLst/>
+                <a:latin typeface="JetBrains Mono"/>
+              </a:rPr>
+              <a:t>R.LastSeenTime</a:t>
+            </a:r>
+            <a:r>
+              <a:rPr lang="en-GB" sz="1800" dirty="0">
+                <a:effectLst/>
+                <a:latin typeface="JetBrains Mono"/>
+              </a:rPr>
+              <a:t>) &gt; </a:t>
+            </a:r>
+            <a:r>
+              <a:rPr lang="en-GB" sz="1800" dirty="0" err="1">
+                <a:effectLst/>
+                <a:latin typeface="JetBrains Mono"/>
+              </a:rPr>
+              <a:t>ThreatMemoryDuration</a:t>
+            </a:r>
+            <a:r>
+              <a:rPr lang="en-GB" sz="1800" dirty="0">
+                <a:effectLst/>
+                <a:latin typeface="JetBrains Mono"/>
+              </a:rPr>
+              <a:t>);</a:t>
+            </a:r>
+            <a:br>
+              <a:rPr lang="en-GB" sz="1800" dirty="0">
+                <a:effectLst/>
+                <a:latin typeface="JetBrains Mono"/>
+              </a:rPr>
+            </a:br>
+            <a:r>
+              <a:rPr lang="en-GB" sz="1800" dirty="0">
+                <a:effectLst/>
+                <a:latin typeface="JetBrains Mono"/>
+              </a:rPr>
+              <a:t>});</a:t>
+            </a:r>
+          </a:p>
+        </p:txBody>
+      </p:sp>
     </p:spTree>
     <p:extLst>
       <p:ext uri="{BB962C8B-B14F-4D97-AF65-F5344CB8AC3E}">
@@ -4176,338 +4508,6 @@
               <a:rPr lang="en-GB" sz="1800" i="1" dirty="0"/>
             </a:br>
             <a:endParaRPr lang="LID4096" dirty="0"/>
-          </a:p>
-        </p:txBody>
-      </p:sp>
-      <p:sp>
-        <p:nvSpPr>
-          <p:cNvPr id="7" name="TextBox 6">
-            <a:extLst>
-              <a:ext uri="{FF2B5EF4-FFF2-40B4-BE49-F238E27FC236}">
-                <a16:creationId xmlns:a16="http://schemas.microsoft.com/office/drawing/2014/main" id="{79A5084E-9CF4-3942-9685-4BF7B41998B1}"/>
-              </a:ext>
-            </a:extLst>
-          </p:cNvPr>
-          <p:cNvSpPr txBox="1"/>
-          <p:nvPr/>
-        </p:nvSpPr>
-        <p:spPr>
-          <a:xfrm>
-            <a:off x="6350171" y="3209605"/>
-            <a:ext cx="6097022" cy="2862322"/>
-          </a:xfrm>
-          <a:prstGeom prst="rect">
-            <a:avLst/>
-          </a:prstGeom>
-          <a:noFill/>
-        </p:spPr>
-        <p:txBody>
-          <a:bodyPr wrap="square">
-            <a:spAutoFit/>
-          </a:bodyPr>
-          <a:lstStyle/>
-          <a:p>
-            <a:pPr>
-              <a:buNone/>
-            </a:pPr>
-            <a:r>
-              <a:rPr lang="en-GB" dirty="0">
-                <a:latin typeface="JetBrains Mono"/>
-              </a:rPr>
-              <a:t>Memory c</a:t>
-            </a:r>
-            <a:r>
-              <a:rPr lang="en-GB" sz="1800" dirty="0">
-                <a:effectLst/>
-                <a:latin typeface="JetBrains Mono"/>
-              </a:rPr>
-              <a:t>ompared to Zombies:</a:t>
-            </a:r>
-          </a:p>
-          <a:p>
-            <a:pPr>
-              <a:buNone/>
-            </a:pPr>
-            <a:r>
-              <a:rPr lang="en-GB" sz="1800" dirty="0" err="1">
-                <a:effectLst/>
-                <a:latin typeface="JetBrains Mono"/>
-              </a:rPr>
-              <a:t>Items.RemoveAll</a:t>
-            </a:r>
-            <a:r>
-              <a:rPr lang="en-GB" sz="1800" dirty="0">
-                <a:effectLst/>
-                <a:latin typeface="JetBrains Mono"/>
-              </a:rPr>
-              <a:t>( [](</a:t>
-            </a:r>
-            <a:r>
-              <a:rPr lang="en-GB" sz="1800" dirty="0" err="1">
-                <a:effectLst/>
-                <a:latin typeface="JetBrains Mono"/>
-              </a:rPr>
-              <a:t>const</a:t>
-            </a:r>
-            <a:r>
-              <a:rPr lang="en-GB" sz="1800" dirty="0">
-                <a:effectLst/>
-                <a:latin typeface="JetBrains Mono"/>
-              </a:rPr>
-              <a:t> </a:t>
-            </a:r>
-            <a:r>
-              <a:rPr lang="en-GB" sz="1800" dirty="0" err="1">
-                <a:effectLst/>
-                <a:latin typeface="JetBrains Mono"/>
-              </a:rPr>
-              <a:t>FPerceivedItem</a:t>
-            </a:r>
-            <a:r>
-              <a:rPr lang="en-GB" sz="1800" dirty="0">
-                <a:effectLst/>
-                <a:latin typeface="JetBrains Mono"/>
-              </a:rPr>
-              <a:t>&amp; R)</a:t>
-            </a:r>
-            <a:br>
-              <a:rPr lang="en-GB" sz="1800" dirty="0">
-                <a:effectLst/>
-                <a:latin typeface="JetBrains Mono"/>
-              </a:rPr>
-            </a:br>
-            <a:r>
-              <a:rPr lang="en-GB" sz="1800" dirty="0">
-                <a:effectLst/>
-                <a:latin typeface="JetBrains Mono"/>
-              </a:rPr>
-              <a:t>{</a:t>
-            </a:r>
-            <a:br>
-              <a:rPr lang="en-GB" sz="1800" dirty="0">
-                <a:effectLst/>
-                <a:latin typeface="JetBrains Mono"/>
-              </a:rPr>
-            </a:br>
-            <a:r>
-              <a:rPr lang="en-GB" sz="1800" dirty="0">
-                <a:effectLst/>
-                <a:latin typeface="JetBrains Mono"/>
-              </a:rPr>
-              <a:t>    return !</a:t>
-            </a:r>
-            <a:r>
-              <a:rPr lang="en-GB" sz="1800" dirty="0" err="1">
-                <a:effectLst/>
-                <a:latin typeface="JetBrains Mono"/>
-              </a:rPr>
-              <a:t>R.Actor.IsValid</a:t>
-            </a:r>
-            <a:r>
-              <a:rPr lang="en-GB" sz="1800" dirty="0">
-                <a:effectLst/>
-                <a:latin typeface="JetBrains Mono"/>
-              </a:rPr>
-              <a:t>() || </a:t>
-            </a:r>
-            <a:r>
-              <a:rPr lang="en-GB" sz="1800" dirty="0" err="1">
-                <a:effectLst/>
-                <a:latin typeface="JetBrains Mono"/>
-              </a:rPr>
-              <a:t>R.Actor</a:t>
-            </a:r>
-            <a:r>
-              <a:rPr lang="en-GB" sz="1800" dirty="0">
-                <a:effectLst/>
-                <a:latin typeface="JetBrains Mono"/>
-              </a:rPr>
-              <a:t>-&gt;</a:t>
-            </a:r>
-            <a:r>
-              <a:rPr lang="en-GB" sz="1800" dirty="0" err="1">
-                <a:effectLst/>
-                <a:latin typeface="JetBrains Mono"/>
-              </a:rPr>
-              <a:t>IsHidden</a:t>
-            </a:r>
-            <a:r>
-              <a:rPr lang="en-GB" sz="1800" dirty="0">
-                <a:effectLst/>
-                <a:latin typeface="JetBrains Mono"/>
-              </a:rPr>
-              <a:t>();</a:t>
-            </a:r>
-            <a:br>
-              <a:rPr lang="en-GB" sz="1800" dirty="0">
-                <a:effectLst/>
-                <a:latin typeface="JetBrains Mono"/>
-              </a:rPr>
-            </a:br>
-            <a:r>
-              <a:rPr lang="en-GB" sz="1800" dirty="0">
-                <a:effectLst/>
-                <a:latin typeface="JetBrains Mono"/>
-              </a:rPr>
-              <a:t>});</a:t>
-            </a:r>
-            <a:br>
-              <a:rPr lang="en-GB" sz="1800" dirty="0">
-                <a:effectLst/>
-                <a:latin typeface="JetBrains Mono"/>
-              </a:rPr>
-            </a:br>
-            <a:r>
-              <a:rPr lang="en-GB" sz="1800" dirty="0" err="1">
-                <a:effectLst/>
-                <a:latin typeface="JetBrains Mono"/>
-              </a:rPr>
-              <a:t>Zombies.RemoveAll</a:t>
-            </a:r>
-            <a:r>
-              <a:rPr lang="en-GB" sz="1800" dirty="0">
-                <a:effectLst/>
-                <a:latin typeface="JetBrains Mono"/>
-              </a:rPr>
-              <a:t>([&amp;](</a:t>
-            </a:r>
-            <a:r>
-              <a:rPr lang="en-GB" sz="1800" dirty="0" err="1">
-                <a:effectLst/>
-                <a:latin typeface="JetBrains Mono"/>
-              </a:rPr>
-              <a:t>const</a:t>
-            </a:r>
-            <a:r>
-              <a:rPr lang="en-GB" sz="1800" dirty="0">
-                <a:effectLst/>
-                <a:latin typeface="JetBrains Mono"/>
-              </a:rPr>
-              <a:t> </a:t>
-            </a:r>
-            <a:r>
-              <a:rPr lang="en-GB" sz="1800" dirty="0" err="1">
-                <a:effectLst/>
-                <a:latin typeface="JetBrains Mono"/>
-              </a:rPr>
-              <a:t>FPerceivedActor</a:t>
-            </a:r>
-            <a:r>
-              <a:rPr lang="en-GB" sz="1800" dirty="0">
-                <a:effectLst/>
-                <a:latin typeface="JetBrains Mono"/>
-              </a:rPr>
-              <a:t>&amp; R)</a:t>
-            </a:r>
-            <a:br>
-              <a:rPr lang="en-GB" sz="1800" dirty="0">
-                <a:effectLst/>
-                <a:latin typeface="JetBrains Mono"/>
-              </a:rPr>
-            </a:br>
-            <a:r>
-              <a:rPr lang="en-GB" sz="1800" dirty="0">
-                <a:effectLst/>
-                <a:latin typeface="JetBrains Mono"/>
-              </a:rPr>
-              <a:t>{</a:t>
-            </a:r>
-            <a:br>
-              <a:rPr lang="en-GB" sz="1800" dirty="0">
-                <a:effectLst/>
-                <a:latin typeface="JetBrains Mono"/>
-              </a:rPr>
-            </a:br>
-            <a:r>
-              <a:rPr lang="en-GB" sz="1800" dirty="0">
-                <a:effectLst/>
-                <a:latin typeface="JetBrains Mono"/>
-              </a:rPr>
-              <a:t>    return !</a:t>
-            </a:r>
-            <a:r>
-              <a:rPr lang="en-GB" sz="1800" dirty="0" err="1">
-                <a:effectLst/>
-                <a:latin typeface="JetBrains Mono"/>
-              </a:rPr>
-              <a:t>R.Actor.IsValid</a:t>
-            </a:r>
-            <a:r>
-              <a:rPr lang="en-GB" sz="1800" dirty="0">
-                <a:effectLst/>
-                <a:latin typeface="JetBrains Mono"/>
-              </a:rPr>
-              <a:t>() || (!</a:t>
-            </a:r>
-            <a:r>
-              <a:rPr lang="en-GB" sz="1800" dirty="0" err="1">
-                <a:effectLst/>
-                <a:latin typeface="JetBrains Mono"/>
-              </a:rPr>
-              <a:t>R.bIsVisible</a:t>
-            </a:r>
-            <a:r>
-              <a:rPr lang="en-GB" sz="1800" dirty="0">
-                <a:effectLst/>
-                <a:latin typeface="JetBrains Mono"/>
-              </a:rPr>
-              <a:t> &amp;&amp; (</a:t>
-            </a:r>
-            <a:r>
-              <a:rPr lang="en-GB" sz="1800" dirty="0" err="1">
-                <a:effectLst/>
-                <a:latin typeface="JetBrains Mono"/>
-              </a:rPr>
-              <a:t>TimeNow</a:t>
-            </a:r>
-            <a:r>
-              <a:rPr lang="en-GB" sz="1800" dirty="0">
-                <a:effectLst/>
-                <a:latin typeface="JetBrains Mono"/>
-              </a:rPr>
-              <a:t> - </a:t>
-            </a:r>
-            <a:r>
-              <a:rPr lang="en-GB" sz="1800" dirty="0" err="1">
-                <a:effectLst/>
-                <a:latin typeface="JetBrains Mono"/>
-              </a:rPr>
-              <a:t>R.LastSeenTime</a:t>
-            </a:r>
-            <a:r>
-              <a:rPr lang="en-GB" sz="1800" dirty="0">
-                <a:effectLst/>
-                <a:latin typeface="JetBrains Mono"/>
-              </a:rPr>
-              <a:t>) &gt; </a:t>
-            </a:r>
-            <a:r>
-              <a:rPr lang="en-GB" sz="1800" dirty="0" err="1">
-                <a:effectLst/>
-                <a:latin typeface="JetBrains Mono"/>
-              </a:rPr>
-              <a:t>ThreatMemoryDuration</a:t>
-            </a:r>
-            <a:r>
-              <a:rPr lang="en-GB" sz="1800" dirty="0">
-                <a:effectLst/>
-                <a:latin typeface="JetBrains Mono"/>
-              </a:rPr>
-              <a:t>);</a:t>
-            </a:r>
-            <a:br>
-              <a:rPr lang="en-GB" sz="1800" dirty="0">
-                <a:effectLst/>
-                <a:latin typeface="JetBrains Mono"/>
-              </a:rPr>
-            </a:br>
-            <a:r>
-              <a:rPr lang="en-GB" sz="1800" dirty="0">
-                <a:effectLst/>
-                <a:latin typeface="JetBrains Mono"/>
-              </a:rPr>
-              <a:t>});</a:t>
-            </a:r>
           </a:p>
         </p:txBody>
       </p:sp>

</xml_diff>

<commit_message>
Engage -> Reposition in Combat change
Transition happens not only if the target is too close, but also if the survivor CAN OUTRUN the threat when Fleeing - checking running speed.
Otherwise, survivor stays fighting. Runners are now killable !!!!!!
</commit_message>
<xml_diff>
--- a/GPP_ZombieAI_AdamovDaniel_2DAE10.pptx
+++ b/GPP_ZombieAI_AdamovDaniel_2DAE10.pptx
@@ -405,7 +405,7 @@
           <a:p>
             <a:fld id="{82085877-2B37-48E7-8B6D-4D4ED486130A}" type="datetimeFigureOut">
               <a:rPr lang="en-BE" smtClean="0"/>
-              <a:t>06/02/2026</a:t>
+              <a:t>06/05/2026</a:t>
             </a:fld>
             <a:endParaRPr lang="en-BE"/>
           </a:p>
@@ -605,7 +605,7 @@
           <a:p>
             <a:fld id="{82085877-2B37-48E7-8B6D-4D4ED486130A}" type="datetimeFigureOut">
               <a:rPr lang="en-BE" smtClean="0"/>
-              <a:t>06/02/2026</a:t>
+              <a:t>06/05/2026</a:t>
             </a:fld>
             <a:endParaRPr lang="en-BE"/>
           </a:p>
@@ -815,7 +815,7 @@
           <a:p>
             <a:fld id="{82085877-2B37-48E7-8B6D-4D4ED486130A}" type="datetimeFigureOut">
               <a:rPr lang="en-BE" smtClean="0"/>
-              <a:t>06/02/2026</a:t>
+              <a:t>06/05/2026</a:t>
             </a:fld>
             <a:endParaRPr lang="en-BE"/>
           </a:p>
@@ -1015,7 +1015,7 @@
           <a:p>
             <a:fld id="{82085877-2B37-48E7-8B6D-4D4ED486130A}" type="datetimeFigureOut">
               <a:rPr lang="en-BE" smtClean="0"/>
-              <a:t>06/02/2026</a:t>
+              <a:t>06/05/2026</a:t>
             </a:fld>
             <a:endParaRPr lang="en-BE"/>
           </a:p>
@@ -1291,7 +1291,7 @@
           <a:p>
             <a:fld id="{82085877-2B37-48E7-8B6D-4D4ED486130A}" type="datetimeFigureOut">
               <a:rPr lang="en-BE" smtClean="0"/>
-              <a:t>06/02/2026</a:t>
+              <a:t>06/05/2026</a:t>
             </a:fld>
             <a:endParaRPr lang="en-BE"/>
           </a:p>
@@ -1559,7 +1559,7 @@
           <a:p>
             <a:fld id="{82085877-2B37-48E7-8B6D-4D4ED486130A}" type="datetimeFigureOut">
               <a:rPr lang="en-BE" smtClean="0"/>
-              <a:t>06/02/2026</a:t>
+              <a:t>06/05/2026</a:t>
             </a:fld>
             <a:endParaRPr lang="en-BE"/>
           </a:p>
@@ -1974,7 +1974,7 @@
           <a:p>
             <a:fld id="{82085877-2B37-48E7-8B6D-4D4ED486130A}" type="datetimeFigureOut">
               <a:rPr lang="en-BE" smtClean="0"/>
-              <a:t>06/02/2026</a:t>
+              <a:t>06/05/2026</a:t>
             </a:fld>
             <a:endParaRPr lang="en-BE"/>
           </a:p>
@@ -2116,7 +2116,7 @@
           <a:p>
             <a:fld id="{82085877-2B37-48E7-8B6D-4D4ED486130A}" type="datetimeFigureOut">
               <a:rPr lang="en-BE" smtClean="0"/>
-              <a:t>06/02/2026</a:t>
+              <a:t>06/05/2026</a:t>
             </a:fld>
             <a:endParaRPr lang="en-BE"/>
           </a:p>
@@ -2229,7 +2229,7 @@
           <a:p>
             <a:fld id="{82085877-2B37-48E7-8B6D-4D4ED486130A}" type="datetimeFigureOut">
               <a:rPr lang="en-BE" smtClean="0"/>
-              <a:t>06/02/2026</a:t>
+              <a:t>06/05/2026</a:t>
             </a:fld>
             <a:endParaRPr lang="en-BE"/>
           </a:p>
@@ -2542,7 +2542,7 @@
           <a:p>
             <a:fld id="{82085877-2B37-48E7-8B6D-4D4ED486130A}" type="datetimeFigureOut">
               <a:rPr lang="en-BE" smtClean="0"/>
-              <a:t>06/02/2026</a:t>
+              <a:t>06/05/2026</a:t>
             </a:fld>
             <a:endParaRPr lang="en-BE"/>
           </a:p>
@@ -2831,7 +2831,7 @@
           <a:p>
             <a:fld id="{82085877-2B37-48E7-8B6D-4D4ED486130A}" type="datetimeFigureOut">
               <a:rPr lang="en-BE" smtClean="0"/>
-              <a:t>06/02/2026</a:t>
+              <a:t>06/05/2026</a:t>
             </a:fld>
             <a:endParaRPr lang="en-BE"/>
           </a:p>
@@ -3074,7 +3074,7 @@
           <a:p>
             <a:fld id="{82085877-2B37-48E7-8B6D-4D4ED486130A}" type="datetimeFigureOut">
               <a:rPr lang="en-BE" smtClean="0"/>
-              <a:t>06/02/2026</a:t>
+              <a:t>06/05/2026</a:t>
             </a:fld>
             <a:endParaRPr lang="en-BE"/>
           </a:p>
@@ -4275,7 +4275,7 @@
         </p:nvSpPr>
         <p:spPr>
           <a:xfrm>
-            <a:off x="730293" y="3479630"/>
+            <a:off x="294572" y="3185782"/>
             <a:ext cx="8665320" cy="923330"/>
           </a:xfrm>
           <a:prstGeom prst="rect">
@@ -4317,7 +4317,7 @@
         </p:nvSpPr>
         <p:spPr>
           <a:xfrm>
-            <a:off x="5256778" y="2665504"/>
+            <a:off x="5864834" y="2192071"/>
             <a:ext cx="6097022" cy="646331"/>
           </a:xfrm>
           <a:prstGeom prst="rect">
@@ -4412,7 +4412,7 @@
         </p:nvSpPr>
         <p:spPr>
           <a:xfrm>
-            <a:off x="4122703" y="4738549"/>
+            <a:off x="6211309" y="3647447"/>
             <a:ext cx="6348597" cy="1754326"/>
           </a:xfrm>
           <a:prstGeom prst="rect">
@@ -4460,6 +4460,181 @@
               <a:rPr lang="en-GB" dirty="0"/>
               <a:t>while taking into account walls and best direction.</a:t>
             </a:r>
+          </a:p>
+        </p:txBody>
+      </p:sp>
+      <p:sp>
+        <p:nvSpPr>
+          <p:cNvPr id="7" name="TextBox 6">
+            <a:extLst>
+              <a:ext uri="{FF2B5EF4-FFF2-40B4-BE49-F238E27FC236}">
+                <a16:creationId xmlns:a16="http://schemas.microsoft.com/office/drawing/2014/main" id="{22BE9DE7-70A5-4C67-698F-CF84ED2D8581}"/>
+              </a:ext>
+            </a:extLst>
+          </p:cNvPr>
+          <p:cNvSpPr txBox="1"/>
+          <p:nvPr/>
+        </p:nvSpPr>
+        <p:spPr>
+          <a:xfrm>
+            <a:off x="0" y="4033684"/>
+            <a:ext cx="7417415" cy="2585323"/>
+          </a:xfrm>
+          <a:prstGeom prst="rect">
+            <a:avLst/>
+          </a:prstGeom>
+          <a:noFill/>
+        </p:spPr>
+        <p:txBody>
+          <a:bodyPr wrap="none" rtlCol="0">
+            <a:spAutoFit/>
+          </a:bodyPr>
+          <a:lstStyle/>
+          <a:p>
+            <a:r>
+              <a:rPr lang="en-GB" dirty="0"/>
+              <a:t>Interesting decision:</a:t>
+            </a:r>
+          </a:p>
+          <a:p>
+            <a:r>
+              <a:rPr lang="" dirty="0"/>
+              <a:t>FSMInstance-&gt;AddTransition( Engage, Reposition, </a:t>
+            </a:r>
+            <a:br>
+              <a:rPr lang="" dirty="0"/>
+            </a:br>
+            <a:r>
+              <a:rPr lang="" dirty="0"/>
+              <a:t>    [DistanceToThreat, MinDist, ThreatSpeed, MySpeed]()</a:t>
+            </a:r>
+            <a:br>
+              <a:rPr lang="" dirty="0"/>
+            </a:br>
+            <a:r>
+              <a:rPr lang="" dirty="0"/>
+              <a:t>    {</a:t>
+            </a:r>
+            <a:br>
+              <a:rPr lang="" dirty="0"/>
+            </a:br>
+            <a:r>
+              <a:rPr lang="" dirty="0"/>
+              <a:t>       const bool bTooClose{ DistanceToThreat() &lt; MinDist };</a:t>
+            </a:r>
+            <a:br>
+              <a:rPr lang="" dirty="0"/>
+            </a:br>
+            <a:r>
+              <a:rPr lang="" dirty="0"/>
+              <a:t>       const bool bCanOutrun{ ThreatSpeed &gt; 0.f &amp;&amp; ThreatSpeed &lt; MySpeed };</a:t>
+            </a:r>
+            <a:br>
+              <a:rPr lang="" dirty="0"/>
+            </a:br>
+            <a:r>
+              <a:rPr lang="" dirty="0"/>
+              <a:t>       return bTooClose &amp;&amp; bCanOutrun;</a:t>
+            </a:r>
+            <a:br>
+              <a:rPr lang="" dirty="0"/>
+            </a:br>
+            <a:r>
+              <a:rPr lang="" dirty="0"/>
+              <a:t>    } );</a:t>
+            </a:r>
+          </a:p>
+          <a:p>
+            <a:endParaRPr lang="LID4096" dirty="0"/>
+          </a:p>
+        </p:txBody>
+      </p:sp>
+      <p:sp>
+        <p:nvSpPr>
+          <p:cNvPr id="10" name="TextBox 9">
+            <a:extLst>
+              <a:ext uri="{FF2B5EF4-FFF2-40B4-BE49-F238E27FC236}">
+                <a16:creationId xmlns:a16="http://schemas.microsoft.com/office/drawing/2014/main" id="{50D20100-5887-E769-4B84-1FCE3FDDB544}"/>
+              </a:ext>
+            </a:extLst>
+          </p:cNvPr>
+          <p:cNvSpPr txBox="1"/>
+          <p:nvPr/>
+        </p:nvSpPr>
+        <p:spPr>
+          <a:xfrm>
+            <a:off x="5866888" y="5633714"/>
+            <a:ext cx="6186008" cy="1218149"/>
+          </a:xfrm>
+          <a:prstGeom prst="rect">
+            <a:avLst/>
+          </a:prstGeom>
+          <a:noFill/>
+        </p:spPr>
+        <p:txBody>
+          <a:bodyPr wrap="square">
+            <a:spAutoFit/>
+          </a:bodyPr>
+          <a:lstStyle/>
+          <a:p>
+            <a:pPr>
+              <a:buNone/>
+            </a:pPr>
+            <a:r>
+              <a:rPr lang="" sz="1800" i="1" dirty="0">
+                <a:solidFill>
+                  <a:srgbClr val="85C46C"/>
+                </a:solidFill>
+                <a:effectLst/>
+                <a:latin typeface="JetBrains Mono"/>
+              </a:rPr>
+              <a:t>// Engage -&gt; Reposition, see if distance is too low.</a:t>
+            </a:r>
+            <a:br>
+              <a:rPr lang="" sz="1800" i="1" dirty="0">
+                <a:solidFill>
+                  <a:srgbClr val="85C46C"/>
+                </a:solidFill>
+                <a:effectLst/>
+                <a:latin typeface="JetBrains Mono"/>
+              </a:rPr>
+            </a:br>
+            <a:r>
+              <a:rPr lang="" sz="1800" i="1" dirty="0">
+                <a:solidFill>
+                  <a:srgbClr val="85C46C"/>
+                </a:solidFill>
+                <a:effectLst/>
+                <a:latin typeface="JetBrains Mono"/>
+              </a:rPr>
+              <a:t>// EXCEPTION: even if distance is low, when facing a Runner, don't transition to Reposition =&gt; stay Fight</a:t>
+            </a:r>
+            <a:br>
+              <a:rPr lang="" sz="1800" i="1" dirty="0">
+                <a:solidFill>
+                  <a:srgbClr val="85C46C"/>
+                </a:solidFill>
+                <a:effectLst/>
+                <a:latin typeface="JetBrains Mono"/>
+              </a:rPr>
+            </a:br>
+            <a:r>
+              <a:rPr lang="" sz="1800" i="1" dirty="0">
+                <a:solidFill>
+                  <a:srgbClr val="85C46C"/>
+                </a:solidFill>
+                <a:effectLst/>
+                <a:latin typeface="JetBrains Mono"/>
+              </a:rPr>
+              <a:t>// =&gt; If can't outrun even when fleeing -&gt; fight</a:t>
+            </a:r>
+            <a:endParaRPr lang="" sz="1800" dirty="0">
+              <a:solidFill>
+                <a:srgbClr val="D0D0D0"/>
+              </a:solidFill>
+              <a:effectLst/>
+              <a:latin typeface="JetBrains Mono"/>
+            </a:endParaRPr>
           </a:p>
         </p:txBody>
       </p:sp>

</xml_diff>